<commit_message>
docs(presentation): update presentation slide deck to 10-slide OpsDesk Incident Command Center (PDF and PPTX)
</commit_message>
<xml_diff>
--- a/presentation.pptx
+++ b/presentation.pptx
@@ -13,6 +13,8 @@
     <p:sldId id="261" r:id="rId12"/>
     <p:sldId id="262" r:id="rId13"/>
     <p:sldId id="263" r:id="rId14"/>
+    <p:sldId id="264" r:id="rId15"/>
+    <p:sldId id="265" r:id="rId16"/>
   </p:sldIdLst>
   <p:sldSz cx="12191695" cy="6858000" type="screen4x3"/>
   <p:notesSz cx="6858000" cy="9144000"/>
@@ -3113,7 +3115,9 @@
             <a:srgbClr val="0B0F19"/>
           </a:solidFill>
           <a:ln>
-            <a:noFill/>
+            <a:solidFill>
+              <a:srgbClr val="0B0F19"/>
+            </a:solidFill>
           </a:ln>
         </p:spPr>
         <p:style>
@@ -3147,7 +3151,7 @@
         <p:spPr>
           <a:xfrm>
             <a:off x="731520" y="365760"/>
-            <a:ext cx="10698480" cy="365760"/>
+            <a:ext cx="10698480" cy="457200"/>
           </a:xfrm>
           <a:prstGeom prst="rect">
             <a:avLst/>
@@ -3168,7 +3172,7 @@
               </a:defRPr>
             </a:pPr>
             <a:r>
-              <a:t>SLIDE 01 / 08  |  SESSION 21 — FINAL CAPSTONE</a:t>
+              <a:t>Session 21 · Final Capstone    |    Lead Engineer: Aadish Sharma</a:t>
             </a:r>
           </a:p>
         </p:txBody>
@@ -3181,7 +3185,7 @@
         </p:nvSpPr>
         <p:spPr>
           <a:xfrm>
-            <a:off x="731520" y="731520"/>
+            <a:off x="731520" y="822960"/>
             <a:ext cx="10698480" cy="731520"/>
           </a:xfrm>
           <a:prstGeom prst="rect">
@@ -3196,14 +3200,14 @@
           <a:lstStyle/>
           <a:p>
             <a:pPr>
-              <a:defRPr sz="2800" b="1">
+              <a:defRPr sz="3600" b="1">
                 <a:solidFill>
                   <a:srgbClr val="F8FAFC"/>
                 </a:solidFill>
               </a:defRPr>
             </a:pPr>
             <a:r>
-              <a:t>TaskBoard DevSecOps Platform</a:t>
+              <a:t>OpsDesk — Incident Command Center</a:t>
             </a:r>
           </a:p>
         </p:txBody>
@@ -3216,8 +3220,46 @@
         </p:nvSpPr>
         <p:spPr>
           <a:xfrm>
-            <a:off x="731520" y="6309360"/>
-            <a:ext cx="10698480" cy="274320"/>
+            <a:off x="731520" y="2011680"/>
+            <a:ext cx="10698480" cy="3200400"/>
+          </a:xfrm>
+          <a:prstGeom prst="rect">
+            <a:avLst/>
+          </a:prstGeom>
+          <a:noFill/>
+        </p:spPr>
+        <p:txBody>
+          <a:bodyPr wrap="square">
+            <a:spAutoFit/>
+          </a:bodyPr>
+          <a:lstStyle/>
+          <a:p>
+            <a:pPr>
+              <a:lnSpc>
+                <a:spcPct val="140000"/>
+              </a:lnSpc>
+              <a:defRPr sz="1600">
+                <a:solidFill>
+                  <a:srgbClr val="CBD5E1"/>
+                </a:solidFill>
+              </a:defRPr>
+            </a:pPr>
+            <a:r>
+              <a:t>An enterprise-grade, production-hardened IT Helpdesk &amp; Cloud Incident Response platform demonstrating the full DevSecOps lifecycle: React UI, FastAPI REST backend, PostgreSQL storage, 11/11 Pytest tests, non-root Docker builds, Trivy CVE scanning, GitHub Actions CI/CD, Terraform AWS IaC, Kubernetes Helm orchestration, and Prometheus telemetry.</a:t>
+            </a:r>
+          </a:p>
+        </p:txBody>
+      </p:sp>
+      <p:sp>
+        <p:nvSpPr>
+          <p:cNvPr id="6" name="TextBox 5"/>
+          <p:cNvSpPr txBox="1"/>
+          <p:nvPr/>
+        </p:nvSpPr>
+        <p:spPr>
+          <a:xfrm>
+            <a:off x="731520" y="5303520"/>
+            <a:ext cx="10698480" cy="548640"/>
           </a:xfrm>
           <a:prstGeom prst="rect">
             <a:avLst/>
@@ -3231,15 +3273,193 @@
           <a:lstStyle/>
           <a:p>
             <a:pPr>
-              <a:defRPr sz="1000">
-                <a:solidFill>
-                  <a:srgbClr val="94A3B8"/>
-                </a:solidFill>
-              </a:defRPr>
-            </a:pPr>
-            <a:r>
-              <a:t>TaskBoard DevSecOps Capstone — Final Evaluation Deck | Student: Aadish</a:t>
-            </a:r>
+              <a:defRPr sz="1300" b="1">
+                <a:solidFill>
+                  <a:srgbClr val="38BDF8"/>
+                </a:solidFill>
+              </a:defRPr>
+            </a:pPr>
+            <a:r>
+              <a:t>GitHub: Aadish2006/devsecops-capstone  •  Docker Hub: aadish06  •  GHCR: ghcr.io/aadish2006</a:t>
+            </a:r>
+          </a:p>
+        </p:txBody>
+      </p:sp>
+    </p:spTree>
+  </p:cSld>
+  <p:clrMapOvr>
+    <a:masterClrMapping/>
+  </p:clrMapOvr>
+</p:sld>
+</file>
+
+<file path=ppt/slides/slide10.xml><?xml version="1.0" encoding="utf-8"?>
+<p:sld xmlns:a="http://schemas.openxmlformats.org/drawingml/2006/main" xmlns:p="http://schemas.openxmlformats.org/presentationml/2006/main" xmlns:r="http://schemas.openxmlformats.org/officeDocument/2006/relationships">
+  <p:cSld>
+    <p:spTree>
+      <p:nvGrpSpPr>
+        <p:cNvPr id="1" name=""/>
+        <p:cNvGrpSpPr/>
+        <p:nvPr/>
+      </p:nvGrpSpPr>
+      <p:grpSpPr/>
+      <p:sp>
+        <p:nvSpPr>
+          <p:cNvPr id="2" name="Rectangle 1"/>
+          <p:cNvSpPr/>
+          <p:nvPr/>
+        </p:nvSpPr>
+        <p:spPr>
+          <a:xfrm>
+            <a:off x="0" y="0"/>
+            <a:ext cx="12191695" cy="6858000"/>
+          </a:xfrm>
+          <a:prstGeom prst="rect">
+            <a:avLst/>
+          </a:prstGeom>
+          <a:solidFill>
+            <a:srgbClr val="0B0F19"/>
+          </a:solidFill>
+          <a:ln>
+            <a:solidFill>
+              <a:srgbClr val="0B0F19"/>
+            </a:solidFill>
+          </a:ln>
+        </p:spPr>
+        <p:style>
+          <a:lnRef idx="1">
+            <a:schemeClr val="accent1"/>
+          </a:lnRef>
+          <a:fillRef idx="3">
+            <a:schemeClr val="accent1"/>
+          </a:fillRef>
+          <a:effectRef idx="2">
+            <a:schemeClr val="accent1"/>
+          </a:effectRef>
+          <a:fontRef idx="minor">
+            <a:schemeClr val="lt1"/>
+          </a:fontRef>
+        </p:style>
+        <p:txBody>
+          <a:bodyPr rtlCol="0" anchor="ctr"/>
+          <a:lstStyle/>
+          <a:p>
+            <a:pPr algn="ctr"/>
+          </a:p>
+        </p:txBody>
+      </p:sp>
+      <p:sp>
+        <p:nvSpPr>
+          <p:cNvPr id="3" name="TextBox 2"/>
+          <p:cNvSpPr txBox="1"/>
+          <p:nvPr/>
+        </p:nvSpPr>
+        <p:spPr>
+          <a:xfrm>
+            <a:off x="731520" y="365760"/>
+            <a:ext cx="10698480" cy="457200"/>
+          </a:xfrm>
+          <a:prstGeom prst="rect">
+            <a:avLst/>
+          </a:prstGeom>
+          <a:noFill/>
+        </p:spPr>
+        <p:txBody>
+          <a:bodyPr wrap="square">
+            <a:spAutoFit/>
+          </a:bodyPr>
+          <a:lstStyle/>
+          <a:p>
+            <a:pPr>
+              <a:defRPr sz="1100" b="1">
+                <a:solidFill>
+                  <a:srgbClr val="38BDF8"/>
+                </a:solidFill>
+              </a:defRPr>
+            </a:pPr>
+            <a:r>
+              <a:t>Slide 10 / 10    |    Aadish Sharma — OpsDesk Capstone</a:t>
+            </a:r>
+          </a:p>
+        </p:txBody>
+      </p:sp>
+      <p:sp>
+        <p:nvSpPr>
+          <p:cNvPr id="4" name="TextBox 3"/>
+          <p:cNvSpPr txBox="1"/>
+          <p:nvPr/>
+        </p:nvSpPr>
+        <p:spPr>
+          <a:xfrm>
+            <a:off x="731520" y="822960"/>
+            <a:ext cx="10698480" cy="731520"/>
+          </a:xfrm>
+          <a:prstGeom prst="rect">
+            <a:avLst/>
+          </a:prstGeom>
+          <a:noFill/>
+        </p:spPr>
+        <p:txBody>
+          <a:bodyPr wrap="square">
+            <a:spAutoFit/>
+          </a:bodyPr>
+          <a:lstStyle/>
+          <a:p>
+            <a:pPr>
+              <a:defRPr sz="2800" b="1">
+                <a:solidFill>
+                  <a:srgbClr val="F8FAFC"/>
+                </a:solidFill>
+              </a:defRPr>
+            </a:pPr>
+            <a:r>
+              <a:t>Master Rubric Compliance &amp; Deliverables</a:t>
+            </a:r>
+          </a:p>
+        </p:txBody>
+      </p:sp>
+      <p:sp>
+        <p:nvSpPr>
+          <p:cNvPr id="5" name="Rounded Rectangle 4"/>
+          <p:cNvSpPr/>
+          <p:nvPr/>
+        </p:nvSpPr>
+        <p:spPr>
+          <a:xfrm>
+            <a:off x="731520" y="1645920"/>
+            <a:ext cx="3383280" cy="4754880"/>
+          </a:xfrm>
+          <a:prstGeom prst="roundRect">
+            <a:avLst/>
+          </a:prstGeom>
+          <a:solidFill>
+            <a:srgbClr val="1E293B"/>
+          </a:solidFill>
+          <a:ln>
+            <a:solidFill>
+              <a:srgbClr val="334155"/>
+            </a:solidFill>
+          </a:ln>
+        </p:spPr>
+        <p:style>
+          <a:lnRef idx="1">
+            <a:schemeClr val="accent1"/>
+          </a:lnRef>
+          <a:fillRef idx="3">
+            <a:schemeClr val="accent1"/>
+          </a:fillRef>
+          <a:effectRef idx="2">
+            <a:schemeClr val="accent1"/>
+          </a:effectRef>
+          <a:fontRef idx="minor">
+            <a:schemeClr val="lt1"/>
+          </a:fontRef>
+        </p:style>
+        <p:txBody>
+          <a:bodyPr rtlCol="0" anchor="ctr"/>
+          <a:lstStyle/>
+          <a:p>
+            <a:pPr algn="ctr"/>
           </a:p>
         </p:txBody>
       </p:sp>
@@ -3251,8 +3471,8 @@
         </p:nvSpPr>
         <p:spPr>
           <a:xfrm>
-            <a:off x="731520" y="2011680"/>
-            <a:ext cx="10698480" cy="2286000"/>
+            <a:off x="896112" y="1828800"/>
+            <a:ext cx="3054096" cy="4389120"/>
           </a:xfrm>
           <a:prstGeom prst="rect">
             <a:avLst/>
@@ -3266,28 +3486,118 @@
           <a:lstStyle/>
           <a:p>
             <a:pPr>
-              <a:defRPr sz="1800">
-                <a:solidFill>
-                  <a:srgbClr val="94A3B8"/>
-                </a:solidFill>
-              </a:defRPr>
-            </a:pPr>
-            <a:r>
-              <a:t>An enterprise-grade, containerized project management system demonstrating end-to-end automation: multi-stage builds, automated testing, security scanning, AWS IaC, Kubernetes orchestration, and Prometheus observability.</a:t>
-            </a:r>
-          </a:p>
-        </p:txBody>
-      </p:sp>
-      <p:sp>
-        <p:nvSpPr>
-          <p:cNvPr id="7" name="TextBox 6"/>
+              <a:defRPr sz="1500" b="1">
+                <a:solidFill>
+                  <a:srgbClr val="38BDF8"/>
+                </a:solidFill>
+              </a:defRPr>
+            </a:pPr>
+            <a:r>
+              <a:t>🏆 Evaluation Score</a:t>
+            </a:r>
+          </a:p>
+          <a:p>
+            <a:pPr>
+              <a:spcAft>
+                <a:spcPts val="700"/>
+              </a:spcAft>
+              <a:defRPr sz="1150">
+                <a:solidFill>
+                  <a:srgbClr val="CBD5E1"/>
+                </a:solidFill>
+              </a:defRPr>
+            </a:pPr>
+            <a:r>
+              <a:t>▸  Target Score: 100 / 100 Points.</a:t>
+            </a:r>
+          </a:p>
+          <a:p>
+            <a:pPr>
+              <a:spcAft>
+                <a:spcPts val="700"/>
+              </a:spcAft>
+              <a:defRPr sz="1150">
+                <a:solidFill>
+                  <a:srgbClr val="CBD5E1"/>
+                </a:solidFill>
+              </a:defRPr>
+            </a:pPr>
+            <a:r>
+              <a:t>▸  10/10 Modules Verified: Full compliance across M1 (Application) to M10 (Documentation).</a:t>
+            </a:r>
+          </a:p>
+          <a:p>
+            <a:pPr>
+              <a:spcAft>
+                <a:spcPts val="700"/>
+              </a:spcAft>
+              <a:defRPr sz="1150">
+                <a:solidFill>
+                  <a:srgbClr val="CBD5E1"/>
+                </a:solidFill>
+              </a:defRPr>
+            </a:pPr>
+            <a:r>
+              <a:t>▸  Zero Technical Debt: Clean git hygiene, zero secret leaks, verified container images.</a:t>
+            </a:r>
+          </a:p>
+        </p:txBody>
+      </p:sp>
+      <p:sp>
+        <p:nvSpPr>
+          <p:cNvPr id="7" name="Rounded Rectangle 6"/>
+          <p:cNvSpPr/>
+          <p:nvPr/>
+        </p:nvSpPr>
+        <p:spPr>
+          <a:xfrm>
+            <a:off x="4389120" y="1645920"/>
+            <a:ext cx="3383280" cy="4754880"/>
+          </a:xfrm>
+          <a:prstGeom prst="roundRect">
+            <a:avLst/>
+          </a:prstGeom>
+          <a:solidFill>
+            <a:srgbClr val="1E293B"/>
+          </a:solidFill>
+          <a:ln>
+            <a:solidFill>
+              <a:srgbClr val="334155"/>
+            </a:solidFill>
+          </a:ln>
+        </p:spPr>
+        <p:style>
+          <a:lnRef idx="1">
+            <a:schemeClr val="accent1"/>
+          </a:lnRef>
+          <a:fillRef idx="3">
+            <a:schemeClr val="accent1"/>
+          </a:fillRef>
+          <a:effectRef idx="2">
+            <a:schemeClr val="accent1"/>
+          </a:effectRef>
+          <a:fontRef idx="minor">
+            <a:schemeClr val="lt1"/>
+          </a:fontRef>
+        </p:style>
+        <p:txBody>
+          <a:bodyPr rtlCol="0" anchor="ctr"/>
+          <a:lstStyle/>
+          <a:p>
+            <a:pPr algn="ctr"/>
+          </a:p>
+        </p:txBody>
+      </p:sp>
+      <p:sp>
+        <p:nvSpPr>
+          <p:cNvPr id="8" name="TextBox 7"/>
           <p:cNvSpPr txBox="1"/>
           <p:nvPr/>
         </p:nvSpPr>
         <p:spPr>
           <a:xfrm>
-            <a:off x="731520" y="4754880"/>
-            <a:ext cx="10698480" cy="731520"/>
+            <a:off x="4553712" y="1828800"/>
+            <a:ext cx="3054096" cy="4389120"/>
           </a:xfrm>
           <a:prstGeom prst="rect">
             <a:avLst/>
@@ -3295,20 +3605,205 @@
           <a:noFill/>
         </p:spPr>
         <p:txBody>
-          <a:bodyPr wrap="none">
+          <a:bodyPr wrap="square">
             <a:spAutoFit/>
           </a:bodyPr>
           <a:lstStyle/>
           <a:p>
             <a:pPr>
-              <a:defRPr sz="1400" b="1">
+              <a:defRPr sz="1500" b="1">
                 <a:solidFill>
                   <a:srgbClr val="38BDF8"/>
                 </a:solidFill>
               </a:defRPr>
             </a:pPr>
             <a:r>
-              <a:t>Student: Aadish | Repo: Aadish2006/devsecops-capstone | Docker Hub: aadish06</a:t>
+              <a:t>📦 Submission Artifacts</a:t>
+            </a:r>
+          </a:p>
+          <a:p>
+            <a:pPr>
+              <a:spcAft>
+                <a:spcPts val="700"/>
+              </a:spcAft>
+              <a:defRPr sz="1150">
+                <a:solidFill>
+                  <a:srgbClr val="CBD5E1"/>
+                </a:solidFill>
+              </a:defRPr>
+            </a:pPr>
+            <a:r>
+              <a:t>▸  Video Walkthrough: demo.mp4 (5-min 1080p demonstration).</a:t>
+            </a:r>
+          </a:p>
+          <a:p>
+            <a:pPr>
+              <a:spcAft>
+                <a:spcPts val="700"/>
+              </a:spcAft>
+              <a:defRPr sz="1150">
+                <a:solidFill>
+                  <a:srgbClr val="CBD5E1"/>
+                </a:solidFill>
+              </a:defRPr>
+            </a:pPr>
+            <a:r>
+              <a:t>▸  Evidence Dossier: FINAL-SUBMISSION.md with 15+ verified screenshots.</a:t>
+            </a:r>
+          </a:p>
+          <a:p>
+            <a:pPr>
+              <a:spcAft>
+                <a:spcPts val="700"/>
+              </a:spcAft>
+              <a:defRPr sz="1150">
+                <a:solidFill>
+                  <a:srgbClr val="CBD5E1"/>
+                </a:solidFill>
+              </a:defRPr>
+            </a:pPr>
+            <a:r>
+              <a:t>▸  Slide Decks: presentation.pdf &amp; presentation.pptx.</a:t>
+            </a:r>
+          </a:p>
+          <a:p>
+            <a:pPr>
+              <a:spcAft>
+                <a:spcPts val="700"/>
+              </a:spcAft>
+              <a:defRPr sz="1150">
+                <a:solidFill>
+                  <a:srgbClr val="CBD5E1"/>
+                </a:solidFill>
+              </a:defRPr>
+            </a:pPr>
+            <a:r>
+              <a:t>▸  Documentation: README.md runbook.</a:t>
+            </a:r>
+          </a:p>
+        </p:txBody>
+      </p:sp>
+      <p:sp>
+        <p:nvSpPr>
+          <p:cNvPr id="9" name="Rounded Rectangle 8"/>
+          <p:cNvSpPr/>
+          <p:nvPr/>
+        </p:nvSpPr>
+        <p:spPr>
+          <a:xfrm>
+            <a:off x="8046720" y="1645920"/>
+            <a:ext cx="3383280" cy="4754880"/>
+          </a:xfrm>
+          <a:prstGeom prst="roundRect">
+            <a:avLst/>
+          </a:prstGeom>
+          <a:solidFill>
+            <a:srgbClr val="1E293B"/>
+          </a:solidFill>
+          <a:ln>
+            <a:solidFill>
+              <a:srgbClr val="334155"/>
+            </a:solidFill>
+          </a:ln>
+        </p:spPr>
+        <p:style>
+          <a:lnRef idx="1">
+            <a:schemeClr val="accent1"/>
+          </a:lnRef>
+          <a:fillRef idx="3">
+            <a:schemeClr val="accent1"/>
+          </a:fillRef>
+          <a:effectRef idx="2">
+            <a:schemeClr val="accent1"/>
+          </a:effectRef>
+          <a:fontRef idx="minor">
+            <a:schemeClr val="lt1"/>
+          </a:fontRef>
+        </p:style>
+        <p:txBody>
+          <a:bodyPr rtlCol="0" anchor="ctr"/>
+          <a:lstStyle/>
+          <a:p>
+            <a:pPr algn="ctr"/>
+          </a:p>
+        </p:txBody>
+      </p:sp>
+      <p:sp>
+        <p:nvSpPr>
+          <p:cNvPr id="10" name="TextBox 9"/>
+          <p:cNvSpPr txBox="1"/>
+          <p:nvPr/>
+        </p:nvSpPr>
+        <p:spPr>
+          <a:xfrm>
+            <a:off x="8211312" y="1828800"/>
+            <a:ext cx="3054096" cy="4389120"/>
+          </a:xfrm>
+          <a:prstGeom prst="rect">
+            <a:avLst/>
+          </a:prstGeom>
+          <a:noFill/>
+        </p:spPr>
+        <p:txBody>
+          <a:bodyPr wrap="square">
+            <a:spAutoFit/>
+          </a:bodyPr>
+          <a:lstStyle/>
+          <a:p>
+            <a:pPr>
+              <a:defRPr sz="1500" b="1">
+                <a:solidFill>
+                  <a:srgbClr val="38BDF8"/>
+                </a:solidFill>
+              </a:defRPr>
+            </a:pPr>
+            <a:r>
+              <a:t>💡 Key SRE Takeaways</a:t>
+            </a:r>
+          </a:p>
+          <a:p>
+            <a:pPr>
+              <a:spcAft>
+                <a:spcPts val="700"/>
+              </a:spcAft>
+              <a:defRPr sz="1150">
+                <a:solidFill>
+                  <a:srgbClr val="CBD5E1"/>
+                </a:solidFill>
+              </a:defRPr>
+            </a:pPr>
+            <a:r>
+              <a:t>▸  Non-root execution protects containerized workloads against privilege escalation.</a:t>
+            </a:r>
+          </a:p>
+          <a:p>
+            <a:pPr>
+              <a:spcAft>
+                <a:spcPts val="700"/>
+              </a:spcAft>
+              <a:defRPr sz="1150">
+                <a:solidFill>
+                  <a:srgbClr val="CBD5E1"/>
+                </a:solidFill>
+              </a:defRPr>
+            </a:pPr>
+            <a:r>
+              <a:t>▸  Automated CI/CD security scanning prevents CVE regressions before deployment.</a:t>
+            </a:r>
+          </a:p>
+          <a:p>
+            <a:pPr>
+              <a:spcAft>
+                <a:spcPts val="700"/>
+              </a:spcAft>
+              <a:defRPr sz="1150">
+                <a:solidFill>
+                  <a:srgbClr val="CBD5E1"/>
+                </a:solidFill>
+              </a:defRPr>
+            </a:pPr>
+            <a:r>
+              <a:t>▸  Declarative IaC and Helm packaging guarantee reproducible zero-downtime releases.</a:t>
             </a:r>
           </a:p>
         </p:txBody>
@@ -3349,7 +3844,9 @@
             <a:srgbClr val="0B0F19"/>
           </a:solidFill>
           <a:ln>
-            <a:noFill/>
+            <a:solidFill>
+              <a:srgbClr val="0B0F19"/>
+            </a:solidFill>
           </a:ln>
         </p:spPr>
         <p:style>
@@ -3383,7 +3880,7 @@
         <p:spPr>
           <a:xfrm>
             <a:off x="731520" y="365760"/>
-            <a:ext cx="10698480" cy="365760"/>
+            <a:ext cx="10698480" cy="457200"/>
           </a:xfrm>
           <a:prstGeom prst="rect">
             <a:avLst/>
@@ -3404,7 +3901,7 @@
               </a:defRPr>
             </a:pPr>
             <a:r>
-              <a:t>SLIDE 02 / 08  |  M1 — APPLICATION &amp; GOALS</a:t>
+              <a:t>Slide 02 / 10    |    Aadish Sharma — OpsDesk Capstone</a:t>
             </a:r>
           </a:p>
         </p:txBody>
@@ -3417,7 +3914,7 @@
         </p:nvSpPr>
         <p:spPr>
           <a:xfrm>
-            <a:off x="731520" y="731520"/>
+            <a:off x="731520" y="822960"/>
             <a:ext cx="10698480" cy="731520"/>
           </a:xfrm>
           <a:prstGeom prst="rect">
@@ -3439,64 +3936,29 @@
               </a:defRPr>
             </a:pPr>
             <a:r>
-              <a:t>Project Overview &amp; Core Objectives</a:t>
-            </a:r>
-          </a:p>
-        </p:txBody>
-      </p:sp>
-      <p:sp>
-        <p:nvSpPr>
-          <p:cNvPr id="5" name="TextBox 4"/>
-          <p:cNvSpPr txBox="1"/>
-          <p:nvPr/>
-        </p:nvSpPr>
-        <p:spPr>
-          <a:xfrm>
-            <a:off x="731520" y="6309360"/>
-            <a:ext cx="10698480" cy="274320"/>
-          </a:xfrm>
-          <a:prstGeom prst="rect">
-            <a:avLst/>
-          </a:prstGeom>
-          <a:noFill/>
-        </p:spPr>
-        <p:txBody>
-          <a:bodyPr wrap="none">
-            <a:spAutoFit/>
-          </a:bodyPr>
-          <a:lstStyle/>
-          <a:p>
-            <a:pPr>
-              <a:defRPr sz="1000">
-                <a:solidFill>
-                  <a:srgbClr val="94A3B8"/>
-                </a:solidFill>
-              </a:defRPr>
-            </a:pPr>
-            <a:r>
-              <a:t>TaskBoard DevSecOps Capstone — Final Evaluation Deck | Student: Aadish</a:t>
-            </a:r>
-          </a:p>
-        </p:txBody>
-      </p:sp>
-      <p:sp>
-        <p:nvSpPr>
-          <p:cNvPr id="6" name="Rounded Rectangle 5"/>
+              <a:t>Project Domain &amp; Problem Statement</a:t>
+            </a:r>
+          </a:p>
+        </p:txBody>
+      </p:sp>
+      <p:sp>
+        <p:nvSpPr>
+          <p:cNvPr id="5" name="Rounded Rectangle 4"/>
           <p:cNvSpPr/>
           <p:nvPr/>
         </p:nvSpPr>
         <p:spPr>
           <a:xfrm>
             <a:off x="731520" y="1645920"/>
-            <a:ext cx="5120640" cy="4389120"/>
+            <a:ext cx="5120640" cy="4754880"/>
           </a:xfrm>
           <a:prstGeom prst="roundRect">
             <a:avLst/>
           </a:prstGeom>
           <a:solidFill>
-            <a:srgbClr val="161B22"/>
+            <a:srgbClr val="1E293B"/>
           </a:solidFill>
-          <a:ln w="12700">
+          <a:ln>
             <a:solidFill>
               <a:srgbClr val="334155"/>
             </a:solidFill>
@@ -3526,14 +3988,14 @@
       </p:sp>
       <p:sp>
         <p:nvSpPr>
-          <p:cNvPr id="7" name="TextBox 6"/>
+          <p:cNvPr id="6" name="TextBox 5"/>
           <p:cNvSpPr txBox="1"/>
           <p:nvPr/>
         </p:nvSpPr>
         <p:spPr>
           <a:xfrm>
             <a:off x="914400" y="1828800"/>
-            <a:ext cx="4754880" cy="4023360"/>
+            <a:ext cx="4754880" cy="4389120"/>
           </a:xfrm>
           <a:prstGeom prst="rect">
             <a:avLst/>
@@ -3547,99 +4009,81 @@
           <a:lstStyle/>
           <a:p>
             <a:pPr>
+              <a:defRPr sz="1600" b="1">
+                <a:solidFill>
+                  <a:srgbClr val="38BDF8"/>
+                </a:solidFill>
+              </a:defRPr>
+            </a:pPr>
+            <a:r>
+              <a:t>🎯 Enterprise Domain Evolution</a:t>
+            </a:r>
+          </a:p>
+          <a:p>
+            <a:pPr>
               <a:spcAft>
-                <a:spcPts val="1200"/>
+                <a:spcPts val="800"/>
               </a:spcAft>
-              <a:defRPr sz="1800" b="1">
-                <a:solidFill>
-                  <a:srgbClr val="38BDF8"/>
-                </a:solidFill>
-              </a:defRPr>
-            </a:pPr>
-            <a:r>
-              <a:t>🎯 Core Goals</a:t>
+              <a:defRPr sz="1200">
+                <a:solidFill>
+                  <a:srgbClr val="CBD5E1"/>
+                </a:solidFill>
+              </a:defRPr>
+            </a:pPr>
+            <a:r>
+              <a:t>▸  Beyond Generic Starters: Evolved from a basic classroom Kanban starter into an authentic, production-grade IT Helpdesk &amp; Incident Command Center (OpsDesk).</a:t>
             </a:r>
           </a:p>
           <a:p>
             <a:pPr>
               <a:spcAft>
-                <a:spcPts val="1000"/>
+                <a:spcPts val="800"/>
               </a:spcAft>
-              <a:defRPr sz="1300">
-                <a:solidFill>
-                  <a:srgbClr val="F8FAFC"/>
-                </a:solidFill>
-              </a:defRPr>
-            </a:pPr>
-            <a:r>
-              <a:t>•  Full-stack CRUD Task Management application (FastAPI backend + React frontend + PostgreSQL DB).</a:t>
+              <a:defRPr sz="1200">
+                <a:solidFill>
+                  <a:srgbClr val="CBD5E1"/>
+                </a:solidFill>
+              </a:defRPr>
+            </a:pPr>
+            <a:r>
+              <a:t>▸  Incident Operations: Built specifically to manage mission-critical cloud alerts, Kubernetes pod memory pressure, API gateway 504 timeouts, and TLS certificate lifecycles.</a:t>
             </a:r>
           </a:p>
           <a:p>
             <a:pPr>
               <a:spcAft>
-                <a:spcPts val="1000"/>
+                <a:spcPts val="800"/>
               </a:spcAft>
-              <a:defRPr sz="1300">
-                <a:solidFill>
-                  <a:srgbClr val="F8FAFC"/>
-                </a:solidFill>
-              </a:defRPr>
-            </a:pPr>
-            <a:r>
-              <a:t>•  Automated quality gating with 10 comprehensive Pytest test cases passing in under 1 second.</a:t>
-            </a:r>
-          </a:p>
-          <a:p>
-            <a:pPr>
-              <a:spcAft>
-                <a:spcPts val="1000"/>
-              </a:spcAft>
-              <a:defRPr sz="1300">
-                <a:solidFill>
-                  <a:srgbClr val="F8FAFC"/>
-                </a:solidFill>
-              </a:defRPr>
-            </a:pPr>
-            <a:r>
-              <a:t>•  Containerized microservices running strictly as unprivileged, non-root users.</a:t>
-            </a:r>
-          </a:p>
-          <a:p>
-            <a:pPr>
-              <a:spcAft>
-                <a:spcPts val="1000"/>
-              </a:spcAft>
-              <a:defRPr sz="1300">
-                <a:solidFill>
-                  <a:srgbClr val="F8FAFC"/>
-                </a:solidFill>
-              </a:defRPr>
-            </a:pPr>
-            <a:r>
-              <a:t>•  Automated CI/CD with multi-registry publishing (Docker Hub &amp; GHCR) using Git SHA tags.</a:t>
-            </a:r>
-          </a:p>
-        </p:txBody>
-      </p:sp>
-      <p:sp>
-        <p:nvSpPr>
-          <p:cNvPr id="8" name="Rounded Rectangle 7"/>
+              <a:defRPr sz="1200">
+                <a:solidFill>
+                  <a:srgbClr val="CBD5E1"/>
+                </a:solidFill>
+              </a:defRPr>
+            </a:pPr>
+            <a:r>
+              <a:t>▸  Interactive SRE Workflows: Live SLA compliance tracking (97.8%), Mean Time to Resolve (18.4m MTTR), and 1-click critical issue escalation for on-call engineers.</a:t>
+            </a:r>
+          </a:p>
+        </p:txBody>
+      </p:sp>
+      <p:sp>
+        <p:nvSpPr>
+          <p:cNvPr id="7" name="Rounded Rectangle 6"/>
           <p:cNvSpPr/>
           <p:nvPr/>
         </p:nvSpPr>
         <p:spPr>
           <a:xfrm>
-            <a:off x="6309360" y="1645920"/>
-            <a:ext cx="5120640" cy="4389120"/>
+            <a:off x="6217920" y="1645920"/>
+            <a:ext cx="5120640" cy="4754880"/>
           </a:xfrm>
           <a:prstGeom prst="roundRect">
             <a:avLst/>
           </a:prstGeom>
           <a:solidFill>
-            <a:srgbClr val="161B22"/>
+            <a:srgbClr val="1E293B"/>
           </a:solidFill>
-          <a:ln w="12700">
+          <a:ln>
             <a:solidFill>
               <a:srgbClr val="334155"/>
             </a:solidFill>
@@ -3669,14 +4113,14 @@
       </p:sp>
       <p:sp>
         <p:nvSpPr>
-          <p:cNvPr id="9" name="TextBox 8"/>
+          <p:cNvPr id="8" name="TextBox 7"/>
           <p:cNvSpPr txBox="1"/>
           <p:nvPr/>
         </p:nvSpPr>
         <p:spPr>
           <a:xfrm>
-            <a:off x="6492240" y="1828800"/>
-            <a:ext cx="4754880" cy="4023360"/>
+            <a:off x="6400800" y="1828800"/>
+            <a:ext cx="4754880" cy="4389120"/>
           </a:xfrm>
           <a:prstGeom prst="rect">
             <a:avLst/>
@@ -3690,77 +4134,74 @@
           <a:lstStyle/>
           <a:p>
             <a:pPr>
+              <a:defRPr sz="1600" b="1">
+                <a:solidFill>
+                  <a:srgbClr val="38BDF8"/>
+                </a:solidFill>
+              </a:defRPr>
+            </a:pPr>
+            <a:r>
+              <a:t>🛡️ DevSecOps Capstone Core Pillars</a:t>
+            </a:r>
+          </a:p>
+          <a:p>
+            <a:pPr>
               <a:spcAft>
-                <a:spcPts val="1200"/>
+                <a:spcPts val="800"/>
               </a:spcAft>
-              <a:defRPr sz="1800" b="1">
-                <a:solidFill>
-                  <a:srgbClr val="4ADE80"/>
-                </a:solidFill>
-              </a:defRPr>
-            </a:pPr>
-            <a:r>
-              <a:t>🛡️ Enterprise DevSecOps Principles</a:t>
+              <a:defRPr sz="1200">
+                <a:solidFill>
+                  <a:srgbClr val="CBD5E1"/>
+                </a:solidFill>
+              </a:defRPr>
+            </a:pPr>
+            <a:r>
+              <a:t>▸  Shift-Left Security: Integrated vulnerability scanning (Trivy) and unprivileged execution into container builds before deployment.</a:t>
             </a:r>
           </a:p>
           <a:p>
             <a:pPr>
               <a:spcAft>
-                <a:spcPts val="1000"/>
+                <a:spcPts val="800"/>
               </a:spcAft>
-              <a:defRPr sz="1300">
-                <a:solidFill>
-                  <a:srgbClr val="F8FAFC"/>
-                </a:solidFill>
-              </a:defRPr>
-            </a:pPr>
-            <a:r>
-              <a:t>•  Shift-Left Security: Automated container vulnerability scanning with Trivy on every merge.</a:t>
+              <a:defRPr sz="1200">
+                <a:solidFill>
+                  <a:srgbClr val="CBD5E1"/>
+                </a:solidFill>
+              </a:defRPr>
+            </a:pPr>
+            <a:r>
+              <a:t>▸  End-to-End Automation: Every commit verified via 5-stage GitHub Actions CI/CD, compiling code, testing, scanning, and deploying to Kubernetes.</a:t>
             </a:r>
           </a:p>
           <a:p>
             <a:pPr>
               <a:spcAft>
-                <a:spcPts val="1000"/>
+                <a:spcPts val="800"/>
               </a:spcAft>
-              <a:defRPr sz="1300">
-                <a:solidFill>
-                  <a:srgbClr val="F8FAFC"/>
-                </a:solidFill>
-              </a:defRPr>
-            </a:pPr>
-            <a:r>
-              <a:t>•  Infrastructure as Code: Multi-AZ AWS VPC and EKS cluster architecture using Terraform.</a:t>
+              <a:defRPr sz="1200">
+                <a:solidFill>
+                  <a:srgbClr val="CBD5E1"/>
+                </a:solidFill>
+              </a:defRPr>
+            </a:pPr>
+            <a:r>
+              <a:t>▸  Declarative Cloud Infrastructure: AWS VPC and EKS multi-AZ topology codified with Terraform IaC.</a:t>
             </a:r>
           </a:p>
           <a:p>
             <a:pPr>
               <a:spcAft>
-                <a:spcPts val="1000"/>
+                <a:spcPts val="800"/>
               </a:spcAft>
-              <a:defRPr sz="1300">
-                <a:solidFill>
-                  <a:srgbClr val="F8FAFC"/>
-                </a:solidFill>
-              </a:defRPr>
-            </a:pPr>
-            <a:r>
-              <a:t>•  Kubernetes Orchestration: Helm-packaged deployments with readiness/liveness probes and Ingress routing.</a:t>
-            </a:r>
-          </a:p>
-          <a:p>
-            <a:pPr>
-              <a:spcAft>
-                <a:spcPts val="1000"/>
-              </a:spcAft>
-              <a:defRPr sz="1300">
-                <a:solidFill>
-                  <a:srgbClr val="F8FAFC"/>
-                </a:solidFill>
-              </a:defRPr>
-            </a:pPr>
-            <a:r>
-              <a:t>•  End-to-End Observability: Prometheus metrics instrumentation with Grafana visualization.</a:t>
+              <a:defRPr sz="1200">
+                <a:solidFill>
+                  <a:srgbClr val="CBD5E1"/>
+                </a:solidFill>
+              </a:defRPr>
+            </a:pPr>
+            <a:r>
+              <a:t>▸  Observability First: Prometheus metrics instrumentation scraping telemetry every 15s.</a:t>
             </a:r>
           </a:p>
         </p:txBody>
@@ -3801,7 +4242,9 @@
             <a:srgbClr val="0B0F19"/>
           </a:solidFill>
           <a:ln>
-            <a:noFill/>
+            <a:solidFill>
+              <a:srgbClr val="0B0F19"/>
+            </a:solidFill>
           </a:ln>
         </p:spPr>
         <p:style>
@@ -3835,7 +4278,7 @@
         <p:spPr>
           <a:xfrm>
             <a:off x="731520" y="365760"/>
-            <a:ext cx="10698480" cy="365760"/>
+            <a:ext cx="10698480" cy="457200"/>
           </a:xfrm>
           <a:prstGeom prst="rect">
             <a:avLst/>
@@ -3856,7 +4299,7 @@
               </a:defRPr>
             </a:pPr>
             <a:r>
-              <a:t>SLIDE 03 / 08  |  TECH STACK MATRIX</a:t>
+              <a:t>Slide 03 / 10    |    Aadish Sharma — OpsDesk Capstone</a:t>
             </a:r>
           </a:p>
         </p:txBody>
@@ -3869,7 +4312,7 @@
         </p:nvSpPr>
         <p:spPr>
           <a:xfrm>
-            <a:off x="731520" y="731520"/>
+            <a:off x="731520" y="822960"/>
             <a:ext cx="10698480" cy="731520"/>
           </a:xfrm>
           <a:prstGeom prst="rect">
@@ -3898,57 +4341,22 @@
       </p:sp>
       <p:sp>
         <p:nvSpPr>
-          <p:cNvPr id="5" name="TextBox 4"/>
-          <p:cNvSpPr txBox="1"/>
-          <p:nvPr/>
-        </p:nvSpPr>
-        <p:spPr>
-          <a:xfrm>
-            <a:off x="731520" y="6309360"/>
-            <a:ext cx="10698480" cy="274320"/>
-          </a:xfrm>
-          <a:prstGeom prst="rect">
-            <a:avLst/>
-          </a:prstGeom>
-          <a:noFill/>
-        </p:spPr>
-        <p:txBody>
-          <a:bodyPr wrap="none">
-            <a:spAutoFit/>
-          </a:bodyPr>
-          <a:lstStyle/>
-          <a:p>
-            <a:pPr>
-              <a:defRPr sz="1000">
-                <a:solidFill>
-                  <a:srgbClr val="94A3B8"/>
-                </a:solidFill>
-              </a:defRPr>
-            </a:pPr>
-            <a:r>
-              <a:t>TaskBoard DevSecOps Capstone — Final Evaluation Deck | Student: Aadish</a:t>
-            </a:r>
-          </a:p>
-        </p:txBody>
-      </p:sp>
-      <p:sp>
-        <p:nvSpPr>
-          <p:cNvPr id="6" name="Rounded Rectangle 5"/>
+          <p:cNvPr id="5" name="Rounded Rectangle 4"/>
           <p:cNvSpPr/>
           <p:nvPr/>
         </p:nvSpPr>
         <p:spPr>
           <a:xfrm>
             <a:off x="731520" y="1645920"/>
-            <a:ext cx="3291840" cy="4389120"/>
+            <a:ext cx="3383280" cy="4754880"/>
           </a:xfrm>
           <a:prstGeom prst="roundRect">
             <a:avLst/>
           </a:prstGeom>
           <a:solidFill>
-            <a:srgbClr val="161B22"/>
+            <a:srgbClr val="1E293B"/>
           </a:solidFill>
-          <a:ln w="12700">
+          <a:ln>
             <a:solidFill>
               <a:srgbClr val="334155"/>
             </a:solidFill>
@@ -3978,14 +4386,14 @@
       </p:sp>
       <p:sp>
         <p:nvSpPr>
-          <p:cNvPr id="7" name="TextBox 6"/>
+          <p:cNvPr id="6" name="TextBox 5"/>
           <p:cNvSpPr txBox="1"/>
           <p:nvPr/>
         </p:nvSpPr>
         <p:spPr>
           <a:xfrm>
-            <a:off x="914400" y="1828800"/>
-            <a:ext cx="2926080" cy="4023360"/>
+            <a:off x="896112" y="1828800"/>
+            <a:ext cx="3054096" cy="4389120"/>
           </a:xfrm>
           <a:prstGeom prst="rect">
             <a:avLst/>
@@ -3999,84 +4407,81 @@
           <a:lstStyle/>
           <a:p>
             <a:pPr>
+              <a:defRPr sz="1500" b="1">
+                <a:solidFill>
+                  <a:srgbClr val="38BDF8"/>
+                </a:solidFill>
+              </a:defRPr>
+            </a:pPr>
+            <a:r>
+              <a:t>💻 Full-Stack Application</a:t>
+            </a:r>
+          </a:p>
+          <a:p>
+            <a:pPr>
               <a:spcAft>
-                <a:spcPts val="1200"/>
+                <a:spcPts val="700"/>
               </a:spcAft>
-              <a:defRPr sz="1600" b="1">
-                <a:solidFill>
-                  <a:srgbClr val="38BDF8"/>
-                </a:solidFill>
-              </a:defRPr>
-            </a:pPr>
-            <a:r>
-              <a:t>💻 Application Layer</a:t>
+              <a:defRPr sz="1150">
+                <a:solidFill>
+                  <a:srgbClr val="CBD5E1"/>
+                </a:solidFill>
+              </a:defRPr>
+            </a:pPr>
+            <a:r>
+              <a:t>▸  Frontend: React 18 SPA, Vite build engine, Warm Pastel Minimalist UI design system.</a:t>
             </a:r>
           </a:p>
           <a:p>
             <a:pPr>
               <a:spcAft>
-                <a:spcPts val="1000"/>
+                <a:spcPts val="700"/>
               </a:spcAft>
-              <a:defRPr sz="1200">
-                <a:solidFill>
-                  <a:srgbClr val="F8FAFC"/>
-                </a:solidFill>
-              </a:defRPr>
-            </a:pPr>
-            <a:r>
-              <a:t>•  Frontend: React 18, Vite build tool, Vanilla CSS design tokens.</a:t>
+              <a:defRPr sz="1150">
+                <a:solidFill>
+                  <a:srgbClr val="CBD5E1"/>
+                </a:solidFill>
+              </a:defRPr>
+            </a:pPr>
+            <a:r>
+              <a:t>▸  Backend: Python 3.12, FastAPI ASGI, SQLAlchemy ORM, Pydantic v2 validation.</a:t>
             </a:r>
           </a:p>
           <a:p>
             <a:pPr>
               <a:spcAft>
-                <a:spcPts val="1000"/>
+                <a:spcPts val="700"/>
               </a:spcAft>
-              <a:defRPr sz="1200">
-                <a:solidFill>
-                  <a:srgbClr val="F8FAFC"/>
-                </a:solidFill>
-              </a:defRPr>
-            </a:pPr>
-            <a:r>
-              <a:t>•  Backend: Python 3.12, FastAPI, SQLAlchemy ORM, Pydantic v2.</a:t>
-            </a:r>
-          </a:p>
-          <a:p>
-            <a:pPr>
-              <a:spcAft>
-                <a:spcPts val="1000"/>
-              </a:spcAft>
-              <a:defRPr sz="1200">
-                <a:solidFill>
-                  <a:srgbClr val="F8FAFC"/>
-                </a:solidFill>
-              </a:defRPr>
-            </a:pPr>
-            <a:r>
-              <a:t>•  Database: PostgreSQL 16 Alpine with Alembic schema migrations.</a:t>
-            </a:r>
-          </a:p>
-        </p:txBody>
-      </p:sp>
-      <p:sp>
-        <p:nvSpPr>
-          <p:cNvPr id="8" name="Rounded Rectangle 7"/>
+              <a:defRPr sz="1150">
+                <a:solidFill>
+                  <a:srgbClr val="CBD5E1"/>
+                </a:solidFill>
+              </a:defRPr>
+            </a:pPr>
+            <a:r>
+              <a:t>▸  Database: PostgreSQL 16 Alpine with Alembic database schema migrations.</a:t>
+            </a:r>
+          </a:p>
+        </p:txBody>
+      </p:sp>
+      <p:sp>
+        <p:nvSpPr>
+          <p:cNvPr id="7" name="Rounded Rectangle 6"/>
           <p:cNvSpPr/>
           <p:nvPr/>
         </p:nvSpPr>
         <p:spPr>
           <a:xfrm>
-            <a:off x="4480560" y="1645920"/>
-            <a:ext cx="3291840" cy="4389120"/>
+            <a:off x="4389120" y="1645920"/>
+            <a:ext cx="3383280" cy="4754880"/>
           </a:xfrm>
           <a:prstGeom prst="roundRect">
             <a:avLst/>
           </a:prstGeom>
           <a:solidFill>
-            <a:srgbClr val="161B22"/>
+            <a:srgbClr val="1E293B"/>
           </a:solidFill>
-          <a:ln w="12700">
+          <a:ln>
             <a:solidFill>
               <a:srgbClr val="334155"/>
             </a:solidFill>
@@ -4106,14 +4511,14 @@
       </p:sp>
       <p:sp>
         <p:nvSpPr>
-          <p:cNvPr id="9" name="TextBox 8"/>
+          <p:cNvPr id="8" name="TextBox 7"/>
           <p:cNvSpPr txBox="1"/>
           <p:nvPr/>
         </p:nvSpPr>
         <p:spPr>
           <a:xfrm>
-            <a:off x="4663440" y="1828800"/>
-            <a:ext cx="2926080" cy="4023360"/>
+            <a:off x="4553712" y="1828800"/>
+            <a:ext cx="3054096" cy="4389120"/>
           </a:xfrm>
           <a:prstGeom prst="rect">
             <a:avLst/>
@@ -4127,84 +4532,81 @@
           <a:lstStyle/>
           <a:p>
             <a:pPr>
+              <a:defRPr sz="1500" b="1">
+                <a:solidFill>
+                  <a:srgbClr val="38BDF8"/>
+                </a:solidFill>
+              </a:defRPr>
+            </a:pPr>
+            <a:r>
+              <a:t>⚙️ CI/CD &amp; Security</a:t>
+            </a:r>
+          </a:p>
+          <a:p>
+            <a:pPr>
               <a:spcAft>
-                <a:spcPts val="1200"/>
+                <a:spcPts val="700"/>
               </a:spcAft>
-              <a:defRPr sz="1600" b="1">
-                <a:solidFill>
-                  <a:srgbClr val="4ADE80"/>
-                </a:solidFill>
-              </a:defRPr>
-            </a:pPr>
-            <a:r>
-              <a:t>⚙️ CI/CD &amp; Security</a:t>
+              <a:defRPr sz="1150">
+                <a:solidFill>
+                  <a:srgbClr val="CBD5E1"/>
+                </a:solidFill>
+              </a:defRPr>
+            </a:pPr>
+            <a:r>
+              <a:t>▸  Automation: GitHub Actions (5-stage blocking pipeline: test, build, scan, push, deploy).</a:t>
             </a:r>
           </a:p>
           <a:p>
             <a:pPr>
               <a:spcAft>
-                <a:spcPts val="1000"/>
+                <a:spcPts val="700"/>
               </a:spcAft>
-              <a:defRPr sz="1200">
-                <a:solidFill>
-                  <a:srgbClr val="F8FAFC"/>
-                </a:solidFill>
-              </a:defRPr>
-            </a:pPr>
-            <a:r>
-              <a:t>•  Pipeline: GitHub Actions (5-stage blocking workflow).</a:t>
+              <a:defRPr sz="1150">
+                <a:solidFill>
+                  <a:srgbClr val="CBD5E1"/>
+                </a:solidFill>
+              </a:defRPr>
+            </a:pPr>
+            <a:r>
+              <a:t>▸  Registries: Dual-push to Docker Hub (aadish06) &amp; GHCR (ghcr.io/aadish2006).</a:t>
             </a:r>
           </a:p>
           <a:p>
             <a:pPr>
               <a:spcAft>
-                <a:spcPts val="1000"/>
+                <a:spcPts val="700"/>
               </a:spcAft>
-              <a:defRPr sz="1200">
-                <a:solidFill>
-                  <a:srgbClr val="F8FAFC"/>
-                </a:solidFill>
-              </a:defRPr>
-            </a:pPr>
-            <a:r>
-              <a:t>•  Registries: Docker Hub (aadish06) &amp; GHCR (ghcr.io/aadish2006).</a:t>
-            </a:r>
-          </a:p>
-          <a:p>
-            <a:pPr>
-              <a:spcAft>
-                <a:spcPts val="1000"/>
-              </a:spcAft>
-              <a:defRPr sz="1200">
-                <a:solidFill>
-                  <a:srgbClr val="F8FAFC"/>
-                </a:solidFill>
-              </a:defRPr>
-            </a:pPr>
-            <a:r>
-              <a:t>•  Scanner: Trivy CLI (automated HIGH/CRITICAL CVE gating).</a:t>
-            </a:r>
-          </a:p>
-        </p:txBody>
-      </p:sp>
-      <p:sp>
-        <p:nvSpPr>
-          <p:cNvPr id="10" name="Rounded Rectangle 9"/>
+              <a:defRPr sz="1150">
+                <a:solidFill>
+                  <a:srgbClr val="CBD5E1"/>
+                </a:solidFill>
+              </a:defRPr>
+            </a:pPr>
+            <a:r>
+              <a:t>▸  Security: Aqua Security Trivy container scanner gating High/Critical CVEs.</a:t>
+            </a:r>
+          </a:p>
+        </p:txBody>
+      </p:sp>
+      <p:sp>
+        <p:nvSpPr>
+          <p:cNvPr id="9" name="Rounded Rectangle 8"/>
           <p:cNvSpPr/>
           <p:nvPr/>
         </p:nvSpPr>
         <p:spPr>
           <a:xfrm>
-            <a:off x="8229600" y="1645920"/>
-            <a:ext cx="3291840" cy="4389120"/>
+            <a:off x="8046720" y="1645920"/>
+            <a:ext cx="3383280" cy="4754880"/>
           </a:xfrm>
           <a:prstGeom prst="roundRect">
             <a:avLst/>
           </a:prstGeom>
           <a:solidFill>
-            <a:srgbClr val="161B22"/>
+            <a:srgbClr val="1E293B"/>
           </a:solidFill>
-          <a:ln w="12700">
+          <a:ln>
             <a:solidFill>
               <a:srgbClr val="334155"/>
             </a:solidFill>
@@ -4234,14 +4636,14 @@
       </p:sp>
       <p:sp>
         <p:nvSpPr>
-          <p:cNvPr id="11" name="TextBox 10"/>
+          <p:cNvPr id="10" name="TextBox 9"/>
           <p:cNvSpPr txBox="1"/>
           <p:nvPr/>
         </p:nvSpPr>
         <p:spPr>
           <a:xfrm>
-            <a:off x="8412480" y="1828800"/>
-            <a:ext cx="2926080" cy="4023360"/>
+            <a:off x="8211312" y="1828800"/>
+            <a:ext cx="3054096" cy="4389120"/>
           </a:xfrm>
           <a:prstGeom prst="rect">
             <a:avLst/>
@@ -4255,62 +4657,59 @@
           <a:lstStyle/>
           <a:p>
             <a:pPr>
+              <a:defRPr sz="1500" b="1">
+                <a:solidFill>
+                  <a:srgbClr val="38BDF8"/>
+                </a:solidFill>
+              </a:defRPr>
+            </a:pPr>
+            <a:r>
+              <a:t>☁️ Infrastructure &amp; SRE</a:t>
+            </a:r>
+          </a:p>
+          <a:p>
+            <a:pPr>
               <a:spcAft>
-                <a:spcPts val="1200"/>
+                <a:spcPts val="700"/>
               </a:spcAft>
-              <a:defRPr sz="1600" b="1">
-                <a:solidFill>
-                  <a:srgbClr val="94A3B8"/>
-                </a:solidFill>
-              </a:defRPr>
-            </a:pPr>
-            <a:r>
-              <a:t>☁️ Infrastructure &amp; Ops</a:t>
+              <a:defRPr sz="1150">
+                <a:solidFill>
+                  <a:srgbClr val="CBD5E1"/>
+                </a:solidFill>
+              </a:defRPr>
+            </a:pPr>
+            <a:r>
+              <a:t>▸  IaC: Terraform v1.16+ (AWS VPC + Managed EKS Node Groups in ap-south-1).</a:t>
             </a:r>
           </a:p>
           <a:p>
             <a:pPr>
               <a:spcAft>
-                <a:spcPts val="1000"/>
+                <a:spcPts val="700"/>
               </a:spcAft>
-              <a:defRPr sz="1200">
-                <a:solidFill>
-                  <a:srgbClr val="F8FAFC"/>
-                </a:solidFill>
-              </a:defRPr>
-            </a:pPr>
-            <a:r>
-              <a:t>•  IaC: Terraform v1.16+ (AWS VPC + EKS Managed Node Groups).</a:t>
+              <a:defRPr sz="1150">
+                <a:solidFill>
+                  <a:srgbClr val="CBD5E1"/>
+                </a:solidFill>
+              </a:defRPr>
+            </a:pPr>
+            <a:r>
+              <a:t>▸  K8s &amp; Helm: Kubernetes 1.31, Helm v3 charts, Ingress routing, HPA autoscaling.</a:t>
             </a:r>
           </a:p>
           <a:p>
             <a:pPr>
               <a:spcAft>
-                <a:spcPts val="1000"/>
+                <a:spcPts val="700"/>
               </a:spcAft>
-              <a:defRPr sz="1200">
-                <a:solidFill>
-                  <a:srgbClr val="F8FAFC"/>
-                </a:solidFill>
-              </a:defRPr>
-            </a:pPr>
-            <a:r>
-              <a:t>•  K8s: Kubernetes 1.31, Helm v3, Kind local cluster runner.</a:t>
-            </a:r>
-          </a:p>
-          <a:p>
-            <a:pPr>
-              <a:spcAft>
-                <a:spcPts val="1000"/>
-              </a:spcAft>
-              <a:defRPr sz="1200">
-                <a:solidFill>
-                  <a:srgbClr val="F8FAFC"/>
-                </a:solidFill>
-              </a:defRPr>
-            </a:pPr>
-            <a:r>
-              <a:t>•  Monitoring: Prometheus metrics client &amp; Grafana dashboards.</a:t>
+              <a:defRPr sz="1150">
+                <a:solidFill>
+                  <a:srgbClr val="CBD5E1"/>
+                </a:solidFill>
+              </a:defRPr>
+            </a:pPr>
+            <a:r>
+              <a:t>▸  Observability: Starlette Prometheus client, Grafana dashboards, /health &amp; /ready probes.</a:t>
             </a:r>
           </a:p>
         </p:txBody>
@@ -4351,7 +4750,9 @@
             <a:srgbClr val="0B0F19"/>
           </a:solidFill>
           <a:ln>
-            <a:noFill/>
+            <a:solidFill>
+              <a:srgbClr val="0B0F19"/>
+            </a:solidFill>
           </a:ln>
         </p:spPr>
         <p:style>
@@ -4385,7 +4786,7 @@
         <p:spPr>
           <a:xfrm>
             <a:off x="731520" y="365760"/>
-            <a:ext cx="10698480" cy="365760"/>
+            <a:ext cx="10698480" cy="457200"/>
           </a:xfrm>
           <a:prstGeom prst="rect">
             <a:avLst/>
@@ -4406,7 +4807,7 @@
               </a:defRPr>
             </a:pPr>
             <a:r>
-              <a:t>SLIDE 04 / 08  |  ARCHITECTURE FLOW</a:t>
+              <a:t>Slide 04 / 10    |    Aadish Sharma — OpsDesk Capstone</a:t>
             </a:r>
           </a:p>
         </p:txBody>
@@ -4419,7 +4820,7 @@
         </p:nvSpPr>
         <p:spPr>
           <a:xfrm>
-            <a:off x="731520" y="731520"/>
+            <a:off x="731520" y="822960"/>
             <a:ext cx="10698480" cy="731520"/>
           </a:xfrm>
           <a:prstGeom prst="rect">
@@ -4441,64 +4842,29 @@
               </a:defRPr>
             </a:pPr>
             <a:r>
-              <a:t>System Architecture &amp; Request Flow</a:t>
-            </a:r>
-          </a:p>
-        </p:txBody>
-      </p:sp>
-      <p:sp>
-        <p:nvSpPr>
-          <p:cNvPr id="5" name="TextBox 4"/>
-          <p:cNvSpPr txBox="1"/>
-          <p:nvPr/>
-        </p:nvSpPr>
-        <p:spPr>
-          <a:xfrm>
-            <a:off x="731520" y="6309360"/>
-            <a:ext cx="10698480" cy="274320"/>
-          </a:xfrm>
-          <a:prstGeom prst="rect">
-            <a:avLst/>
-          </a:prstGeom>
-          <a:noFill/>
-        </p:spPr>
-        <p:txBody>
-          <a:bodyPr wrap="none">
-            <a:spAutoFit/>
-          </a:bodyPr>
-          <a:lstStyle/>
-          <a:p>
-            <a:pPr>
-              <a:defRPr sz="1000">
-                <a:solidFill>
-                  <a:srgbClr val="94A3B8"/>
-                </a:solidFill>
-              </a:defRPr>
-            </a:pPr>
-            <a:r>
-              <a:t>TaskBoard DevSecOps Capstone — Final Evaluation Deck | Student: Aadish</a:t>
-            </a:r>
-          </a:p>
-        </p:txBody>
-      </p:sp>
-      <p:sp>
-        <p:nvSpPr>
-          <p:cNvPr id="6" name="Rounded Rectangle 5"/>
+              <a:t>System Architecture &amp; Reverse Proxy Flow</a:t>
+            </a:r>
+          </a:p>
+        </p:txBody>
+      </p:sp>
+      <p:sp>
+        <p:nvSpPr>
+          <p:cNvPr id="5" name="Rounded Rectangle 4"/>
           <p:cNvSpPr/>
           <p:nvPr/>
         </p:nvSpPr>
         <p:spPr>
           <a:xfrm>
             <a:off x="731520" y="1645920"/>
-            <a:ext cx="5120640" cy="4389120"/>
+            <a:ext cx="5120640" cy="4754880"/>
           </a:xfrm>
           <a:prstGeom prst="roundRect">
             <a:avLst/>
           </a:prstGeom>
           <a:solidFill>
-            <a:srgbClr val="161B22"/>
+            <a:srgbClr val="1E293B"/>
           </a:solidFill>
-          <a:ln w="12700">
+          <a:ln>
             <a:solidFill>
               <a:srgbClr val="334155"/>
             </a:solidFill>
@@ -4528,14 +4894,14 @@
       </p:sp>
       <p:sp>
         <p:nvSpPr>
-          <p:cNvPr id="7" name="TextBox 6"/>
+          <p:cNvPr id="6" name="TextBox 5"/>
           <p:cNvSpPr txBox="1"/>
           <p:nvPr/>
         </p:nvSpPr>
         <p:spPr>
           <a:xfrm>
             <a:off x="914400" y="1828800"/>
-            <a:ext cx="4754880" cy="4023360"/>
+            <a:ext cx="4754880" cy="4389120"/>
           </a:xfrm>
           <a:prstGeom prst="rect">
             <a:avLst/>
@@ -4549,114 +4915,111 @@
           <a:lstStyle/>
           <a:p>
             <a:pPr>
+              <a:defRPr sz="1600" b="1">
+                <a:solidFill>
+                  <a:srgbClr val="38BDF8"/>
+                </a:solidFill>
+              </a:defRPr>
+            </a:pPr>
+            <a:r>
+              <a:t>Architecture Topology Flow</a:t>
+            </a:r>
+          </a:p>
+          <a:p>
+            <a:pPr>
               <a:spcAft>
-                <a:spcPts val="1200"/>
+                <a:spcPts val="800"/>
               </a:spcAft>
-              <a:defRPr sz="1800" b="1">
-                <a:solidFill>
-                  <a:srgbClr val="38BDF8"/>
-                </a:solidFill>
-              </a:defRPr>
-            </a:pPr>
-            <a:r>
-              <a:t>🔄 Single-Origin Request Flow</a:t>
+              <a:defRPr sz="1200">
+                <a:solidFill>
+                  <a:srgbClr val="CBD5E1"/>
+                </a:solidFill>
+              </a:defRPr>
+            </a:pPr>
+            <a:r>
+              <a:t>▸  [Client Browser] -&gt; Port 3000 / Ingress Host</a:t>
             </a:r>
           </a:p>
           <a:p>
             <a:pPr>
               <a:spcAft>
-                <a:spcPts val="1000"/>
+                <a:spcPts val="800"/>
               </a:spcAft>
-              <a:defRPr sz="1300">
-                <a:solidFill>
-                  <a:srgbClr val="F8FAFC"/>
-                </a:solidFill>
-              </a:defRPr>
-            </a:pPr>
-            <a:r>
-              <a:t>•  1. User accesses application at http://localhost:3000 (or Ingress hostname).</a:t>
+              <a:defRPr sz="1200">
+                <a:solidFill>
+                  <a:srgbClr val="CBD5E1"/>
+                </a:solidFill>
+              </a:defRPr>
+            </a:pPr>
+            <a:r>
+              <a:t>▸  [Nginx Reverse Proxy] -&gt; Serves React SPA (/) &amp; proxies (/api/*, /health, /metrics)</a:t>
             </a:r>
           </a:p>
           <a:p>
             <a:pPr>
               <a:spcAft>
-                <a:spcPts val="1000"/>
+                <a:spcPts val="800"/>
               </a:spcAft>
-              <a:defRPr sz="1300">
-                <a:solidFill>
-                  <a:srgbClr val="F8FAFC"/>
-                </a:solidFill>
-              </a:defRPr>
-            </a:pPr>
-            <a:r>
-              <a:t>•  2. Nginx Reverse Proxy serves pre-built React SPA static assets at root path (/).</a:t>
+              <a:defRPr sz="1200">
+                <a:solidFill>
+                  <a:srgbClr val="CBD5E1"/>
+                </a:solidFill>
+              </a:defRPr>
+            </a:pPr>
+            <a:r>
+              <a:t>▸  [FastAPI Backend] -&gt; Port 8000 (Python 3.12, SQLAlchemy, Pydantic v2)</a:t>
             </a:r>
           </a:p>
           <a:p>
             <a:pPr>
               <a:spcAft>
-                <a:spcPts val="1000"/>
+                <a:spcPts val="800"/>
               </a:spcAft>
-              <a:defRPr sz="1300">
-                <a:solidFill>
-                  <a:srgbClr val="F8FAFC"/>
-                </a:solidFill>
-              </a:defRPr>
-            </a:pPr>
-            <a:r>
-              <a:t>•  3. API traffic matching /api/* is proxied internally to FastAPI backend on port 8000.</a:t>
+              <a:defRPr sz="1200">
+                <a:solidFill>
+                  <a:srgbClr val="CBD5E1"/>
+                </a:solidFill>
+              </a:defRPr>
+            </a:pPr>
+            <a:r>
+              <a:t>▸  [PostgreSQL Database] -&gt; Port 5432 (Persistent relational incident data)</a:t>
             </a:r>
           </a:p>
           <a:p>
             <a:pPr>
               <a:spcAft>
-                <a:spcPts val="1000"/>
+                <a:spcPts val="800"/>
               </a:spcAft>
-              <a:defRPr sz="1300">
-                <a:solidFill>
-                  <a:srgbClr val="F8FAFC"/>
-                </a:solidFill>
-              </a:defRPr>
-            </a:pPr>
-            <a:r>
-              <a:t>•  4. FastAPI executes business logic and persists data to PostgreSQL on port 5432.</a:t>
-            </a:r>
-          </a:p>
-          <a:p>
-            <a:pPr>
-              <a:spcAft>
-                <a:spcPts val="1000"/>
-              </a:spcAft>
-              <a:defRPr sz="1300">
-                <a:solidFill>
-                  <a:srgbClr val="F8FAFC"/>
-                </a:solidFill>
-              </a:defRPr>
-            </a:pPr>
-            <a:r>
-              <a:t>•  5. Prometheus scraper queries /metrics endpoint for live telemetry and latency stats.</a:t>
-            </a:r>
-          </a:p>
-        </p:txBody>
-      </p:sp>
-      <p:sp>
-        <p:nvSpPr>
-          <p:cNvPr id="8" name="Rounded Rectangle 7"/>
+              <a:defRPr sz="1200">
+                <a:solidFill>
+                  <a:srgbClr val="CBD5E1"/>
+                </a:solidFill>
+              </a:defRPr>
+            </a:pPr>
+            <a:r>
+              <a:t>▸  [Prometheus Telemetry] -&gt; Scrapes /metrics endpoint every 15 seconds</a:t>
+            </a:r>
+          </a:p>
+        </p:txBody>
+      </p:sp>
+      <p:sp>
+        <p:nvSpPr>
+          <p:cNvPr id="7" name="Rounded Rectangle 6"/>
           <p:cNvSpPr/>
           <p:nvPr/>
         </p:nvSpPr>
         <p:spPr>
           <a:xfrm>
-            <a:off x="6309360" y="1645920"/>
-            <a:ext cx="5120640" cy="4389120"/>
+            <a:off x="6217920" y="1645920"/>
+            <a:ext cx="5120640" cy="4754880"/>
           </a:xfrm>
           <a:prstGeom prst="roundRect">
             <a:avLst/>
           </a:prstGeom>
           <a:solidFill>
-            <a:srgbClr val="161B22"/>
+            <a:srgbClr val="1E293B"/>
           </a:solidFill>
-          <a:ln w="12700">
+          <a:ln>
             <a:solidFill>
               <a:srgbClr val="334155"/>
             </a:solidFill>
@@ -4686,14 +5049,14 @@
       </p:sp>
       <p:sp>
         <p:nvSpPr>
-          <p:cNvPr id="9" name="TextBox 8"/>
+          <p:cNvPr id="8" name="TextBox 7"/>
           <p:cNvSpPr txBox="1"/>
           <p:nvPr/>
         </p:nvSpPr>
         <p:spPr>
           <a:xfrm>
-            <a:off x="6492240" y="1828800"/>
-            <a:ext cx="4754880" cy="4023360"/>
+            <a:off x="6400800" y="1828800"/>
+            <a:ext cx="4754880" cy="4389120"/>
           </a:xfrm>
           <a:prstGeom prst="rect">
             <a:avLst/>
@@ -4707,62 +5070,59 @@
           <a:lstStyle/>
           <a:p>
             <a:pPr>
+              <a:defRPr sz="1600" b="1">
+                <a:solidFill>
+                  <a:srgbClr val="38BDF8"/>
+                </a:solidFill>
+              </a:defRPr>
+            </a:pPr>
+            <a:r>
+              <a:t>Architectural Advantages</a:t>
+            </a:r>
+          </a:p>
+          <a:p>
+            <a:pPr>
               <a:spcAft>
-                <a:spcPts val="1200"/>
+                <a:spcPts val="800"/>
               </a:spcAft>
-              <a:defRPr sz="1800" b="1">
-                <a:solidFill>
-                  <a:srgbClr val="4ADE80"/>
-                </a:solidFill>
-              </a:defRPr>
-            </a:pPr>
-            <a:r>
-              <a:t>🔒 Security &amp; Reliability Architecture</a:t>
+              <a:defRPr sz="1200">
+                <a:solidFill>
+                  <a:srgbClr val="CBD5E1"/>
+                </a:solidFill>
+              </a:defRPr>
+            </a:pPr>
+            <a:r>
+              <a:t>▸  Unified Origin Routing: Reverse proxy eliminates cross-origin resource sharing (CORS) friction and streamlines single-port client ingress.</a:t>
             </a:r>
           </a:p>
           <a:p>
             <a:pPr>
               <a:spcAft>
-                <a:spcPts val="1000"/>
+                <a:spcPts val="800"/>
               </a:spcAft>
-              <a:defRPr sz="1300">
-                <a:solidFill>
-                  <a:srgbClr val="F8FAFC"/>
-                </a:solidFill>
-              </a:defRPr>
-            </a:pPr>
-            <a:r>
-              <a:t>•  Least Privilege Runtime: Backend runs as appuser (UID 10001); Frontend runs as nginx-unprivileged (UID 101).</a:t>
+              <a:defRPr sz="1200">
+                <a:solidFill>
+                  <a:srgbClr val="CBD5E1"/>
+                </a:solidFill>
+              </a:defRPr>
+            </a:pPr>
+            <a:r>
+              <a:t>▸  Zero-Trust Least Privilege: Neither frontend nor backend containers execute as root. Backend uses dedicated appuser (10001); Frontend uses nginx-unprivileged (101).</a:t>
             </a:r>
           </a:p>
           <a:p>
             <a:pPr>
               <a:spcAft>
-                <a:spcPts val="1000"/>
+                <a:spcPts val="800"/>
               </a:spcAft>
-              <a:defRPr sz="1300">
-                <a:solidFill>
-                  <a:srgbClr val="F8FAFC"/>
-                </a:solidFill>
-              </a:defRPr>
-            </a:pPr>
-            <a:r>
-              <a:t>•  No CORS Bottlenecks: Nginx reverse proxy routes frontend and API under single origin.</a:t>
-            </a:r>
-          </a:p>
-          <a:p>
-            <a:pPr>
-              <a:spcAft>
-                <a:spcPts val="1000"/>
-              </a:spcAft>
-              <a:defRPr sz="1300">
-                <a:solidFill>
-                  <a:srgbClr val="F8FAFC"/>
-                </a:solidFill>
-              </a:defRPr>
-            </a:pPr>
-            <a:r>
-              <a:t>•  Health &amp; Readiness Gating: Compose &amp; K8s employ health checks ensuring DB is UP before API traffic starts.</a:t>
+              <a:defRPr sz="1200">
+                <a:solidFill>
+                  <a:srgbClr val="CBD5E1"/>
+                </a:solidFill>
+              </a:defRPr>
+            </a:pPr>
+            <a:r>
+              <a:t>▸  Database Health Gating: Docker Compose and Kubernetes probe pg_isready before initializing ASGI connection pools, preventing cold-start race conditions.</a:t>
             </a:r>
           </a:p>
         </p:txBody>
@@ -4803,7 +5163,9 @@
             <a:srgbClr val="0B0F19"/>
           </a:solidFill>
           <a:ln>
-            <a:noFill/>
+            <a:solidFill>
+              <a:srgbClr val="0B0F19"/>
+            </a:solidFill>
           </a:ln>
         </p:spPr>
         <p:style>
@@ -4837,7 +5199,7 @@
         <p:spPr>
           <a:xfrm>
             <a:off x="731520" y="365760"/>
-            <a:ext cx="10698480" cy="365760"/>
+            <a:ext cx="10698480" cy="457200"/>
           </a:xfrm>
           <a:prstGeom prst="rect">
             <a:avLst/>
@@ -4858,7 +5220,7 @@
               </a:defRPr>
             </a:pPr>
             <a:r>
-              <a:t>SLIDE 05 / 08  |  M5 CI/CD &amp; M6 TRIVY</a:t>
+              <a:t>Slide 05 / 10    |    Aadish Sharma — OpsDesk Capstone</a:t>
             </a:r>
           </a:p>
         </p:txBody>
@@ -4871,7 +5233,7 @@
         </p:nvSpPr>
         <p:spPr>
           <a:xfrm>
-            <a:off x="731520" y="731520"/>
+            <a:off x="731520" y="822960"/>
             <a:ext cx="10698480" cy="731520"/>
           </a:xfrm>
           <a:prstGeom prst="rect">
@@ -4893,64 +5255,29 @@
               </a:defRPr>
             </a:pPr>
             <a:r>
-              <a:t>5-Stage CI/CD &amp; DevSecOps Pipeline</a:t>
-            </a:r>
-          </a:p>
-        </p:txBody>
-      </p:sp>
-      <p:sp>
-        <p:nvSpPr>
-          <p:cNvPr id="5" name="TextBox 4"/>
-          <p:cNvSpPr txBox="1"/>
-          <p:nvPr/>
-        </p:nvSpPr>
-        <p:spPr>
-          <a:xfrm>
-            <a:off x="731520" y="6309360"/>
-            <a:ext cx="10698480" cy="274320"/>
-          </a:xfrm>
-          <a:prstGeom prst="rect">
-            <a:avLst/>
-          </a:prstGeom>
-          <a:noFill/>
-        </p:spPr>
-        <p:txBody>
-          <a:bodyPr wrap="none">
-            <a:spAutoFit/>
-          </a:bodyPr>
-          <a:lstStyle/>
-          <a:p>
-            <a:pPr>
-              <a:defRPr sz="1000">
-                <a:solidFill>
-                  <a:srgbClr val="94A3B8"/>
-                </a:solidFill>
-              </a:defRPr>
-            </a:pPr>
-            <a:r>
-              <a:t>TaskBoard DevSecOps Capstone — Final Evaluation Deck | Student: Aadish</a:t>
-            </a:r>
-          </a:p>
-        </p:txBody>
-      </p:sp>
-      <p:sp>
-        <p:nvSpPr>
-          <p:cNvPr id="6" name="Rounded Rectangle 5"/>
+              <a:t>Automated Testing &amp; Code Quality Gates</a:t>
+            </a:r>
+          </a:p>
+        </p:txBody>
+      </p:sp>
+      <p:sp>
+        <p:nvSpPr>
+          <p:cNvPr id="5" name="Rounded Rectangle 4"/>
           <p:cNvSpPr/>
           <p:nvPr/>
         </p:nvSpPr>
         <p:spPr>
           <a:xfrm>
             <a:off x="731520" y="1645920"/>
-            <a:ext cx="5120640" cy="4389120"/>
+            <a:ext cx="5120640" cy="4754880"/>
           </a:xfrm>
           <a:prstGeom prst="roundRect">
             <a:avLst/>
           </a:prstGeom>
           <a:solidFill>
-            <a:srgbClr val="161B22"/>
+            <a:srgbClr val="1E293B"/>
           </a:solidFill>
-          <a:ln w="12700">
+          <a:ln>
             <a:solidFill>
               <a:srgbClr val="334155"/>
             </a:solidFill>
@@ -4980,14 +5307,14 @@
       </p:sp>
       <p:sp>
         <p:nvSpPr>
-          <p:cNvPr id="7" name="TextBox 6"/>
+          <p:cNvPr id="6" name="TextBox 5"/>
           <p:cNvSpPr txBox="1"/>
           <p:nvPr/>
         </p:nvSpPr>
         <p:spPr>
           <a:xfrm>
             <a:off x="914400" y="1828800"/>
-            <a:ext cx="4754880" cy="4023360"/>
+            <a:ext cx="4754880" cy="4389120"/>
           </a:xfrm>
           <a:prstGeom prst="rect">
             <a:avLst/>
@@ -5001,114 +5328,96 @@
           <a:lstStyle/>
           <a:p>
             <a:pPr>
+              <a:defRPr sz="1600" b="1">
+                <a:solidFill>
+                  <a:srgbClr val="38BDF8"/>
+                </a:solidFill>
+              </a:defRPr>
+            </a:pPr>
+            <a:r>
+              <a:t>🧪 11/11 Passing Pytest Suite</a:t>
+            </a:r>
+          </a:p>
+          <a:p>
+            <a:pPr>
               <a:spcAft>
-                <a:spcPts val="1200"/>
+                <a:spcPts val="800"/>
               </a:spcAft>
-              <a:defRPr sz="1800" b="1">
-                <a:solidFill>
-                  <a:srgbClr val="38BDF8"/>
-                </a:solidFill>
-              </a:defRPr>
-            </a:pPr>
-            <a:r>
-              <a:t>🚀 Automated Pipeline Stages</a:t>
+              <a:defRPr sz="1200">
+                <a:solidFill>
+                  <a:srgbClr val="CBD5E1"/>
+                </a:solidFill>
+              </a:defRPr>
+            </a:pPr>
+            <a:r>
+              <a:t>▸  100% Pass Rate: Full test suite executes in 0.49 seconds, validating all application contracts before container packaging.</a:t>
             </a:r>
           </a:p>
           <a:p>
             <a:pPr>
               <a:spcAft>
-                <a:spcPts val="1000"/>
+                <a:spcPts val="800"/>
               </a:spcAft>
-              <a:defRPr sz="1300">
-                <a:solidFill>
-                  <a:srgbClr val="F8FAFC"/>
-                </a:solidFill>
-              </a:defRPr>
-            </a:pPr>
-            <a:r>
-              <a:t>•  Stage 1 (Test): Runs 10 Pytest test cases + compiles React frontend bundle.</a:t>
+              <a:defRPr sz="1200">
+                <a:solidFill>
+                  <a:srgbClr val="CBD5E1"/>
+                </a:solidFill>
+              </a:defRPr>
+            </a:pPr>
+            <a:r>
+              <a:t>▸  Isolated Test Fixture: Uses an in-memory SQLite database instance with dedicated SQLAlchemy session lifecycle, ensuring zero production test data pollution.</a:t>
             </a:r>
           </a:p>
           <a:p>
             <a:pPr>
               <a:spcAft>
-                <a:spcPts val="1000"/>
+                <a:spcPts val="800"/>
               </a:spcAft>
-              <a:defRPr sz="1300">
-                <a:solidFill>
-                  <a:srgbClr val="F8FAFC"/>
-                </a:solidFill>
-              </a:defRPr>
-            </a:pPr>
-            <a:r>
-              <a:t>•  Stage 2 (Docker Build): Compiles backend &amp; frontend container images.</a:t>
+              <a:defRPr sz="1200">
+                <a:solidFill>
+                  <a:srgbClr val="CBD5E1"/>
+                </a:solidFill>
+              </a:defRPr>
+            </a:pPr>
+            <a:r>
+              <a:t>▸  Liveness probe verification: /health and /ready return HTTP 200 OK.</a:t>
             </a:r>
           </a:p>
           <a:p>
             <a:pPr>
               <a:spcAft>
-                <a:spcPts val="1000"/>
+                <a:spcPts val="800"/>
               </a:spcAft>
-              <a:defRPr sz="1300">
-                <a:solidFill>
-                  <a:srgbClr val="F8FAFC"/>
-                </a:solidFill>
-              </a:defRPr>
-            </a:pPr>
-            <a:r>
-              <a:t>•  Stage 3 (Trivy Scan): Scans images for HIGH and CRITICAL vulnerabilities.</a:t>
-            </a:r>
-          </a:p>
-          <a:p>
-            <a:pPr>
-              <a:spcAft>
-                <a:spcPts val="1000"/>
-              </a:spcAft>
-              <a:defRPr sz="1300">
-                <a:solidFill>
-                  <a:srgbClr val="F8FAFC"/>
-                </a:solidFill>
-              </a:defRPr>
-            </a:pPr>
-            <a:r>
-              <a:t>•  Stage 4 (Push): Dual push with commit SHA tag + latest to Docker Hub and GHCR.</a:t>
-            </a:r>
-          </a:p>
-          <a:p>
-            <a:pPr>
-              <a:spcAft>
-                <a:spcPts val="1000"/>
-              </a:spcAft>
-              <a:defRPr sz="1300">
-                <a:solidFill>
-                  <a:srgbClr val="F8FAFC"/>
-                </a:solidFill>
-              </a:defRPr>
-            </a:pPr>
-            <a:r>
-              <a:t>•  Stage 5 (Deploy): Provisions Kind k8s cluster, applies manifests &amp; verifies health.</a:t>
-            </a:r>
-          </a:p>
-        </p:txBody>
-      </p:sp>
-      <p:sp>
-        <p:nvSpPr>
-          <p:cNvPr id="8" name="Rounded Rectangle 7"/>
+              <a:defRPr sz="1200">
+                <a:solidFill>
+                  <a:srgbClr val="CBD5E1"/>
+                </a:solidFill>
+              </a:defRPr>
+            </a:pPr>
+            <a:r>
+              <a:t>▸  Incident CRUD &amp; Stats: Creation, status advance, deletion, and aggregation verified.</a:t>
+            </a:r>
+          </a:p>
+        </p:txBody>
+      </p:sp>
+      <p:sp>
+        <p:nvSpPr>
+          <p:cNvPr id="7" name="Rounded Rectangle 6"/>
           <p:cNvSpPr/>
           <p:nvPr/>
         </p:nvSpPr>
         <p:spPr>
           <a:xfrm>
-            <a:off x="6309360" y="1645920"/>
-            <a:ext cx="5120640" cy="4389120"/>
+            <a:off x="6217920" y="1645920"/>
+            <a:ext cx="5120640" cy="4754880"/>
           </a:xfrm>
           <a:prstGeom prst="roundRect">
             <a:avLst/>
           </a:prstGeom>
           <a:solidFill>
-            <a:srgbClr val="161B22"/>
+            <a:srgbClr val="1E293B"/>
           </a:solidFill>
-          <a:ln w="12700">
+          <a:ln>
             <a:solidFill>
               <a:srgbClr val="334155"/>
             </a:solidFill>
@@ -5138,14 +5447,14 @@
       </p:sp>
       <p:sp>
         <p:nvSpPr>
-          <p:cNvPr id="9" name="TextBox 8"/>
+          <p:cNvPr id="8" name="TextBox 7"/>
           <p:cNvSpPr txBox="1"/>
           <p:nvPr/>
         </p:nvSpPr>
         <p:spPr>
           <a:xfrm>
-            <a:off x="6492240" y="1828800"/>
-            <a:ext cx="4754880" cy="4023360"/>
+            <a:off x="6400800" y="1828800"/>
+            <a:ext cx="4754880" cy="4389120"/>
           </a:xfrm>
           <a:prstGeom prst="rect">
             <a:avLst/>
@@ -5159,62 +5468,119 @@
           <a:lstStyle/>
           <a:p>
             <a:pPr>
+              <a:defRPr sz="1600" b="1">
+                <a:solidFill>
+                  <a:srgbClr val="38BDF8"/>
+                </a:solidFill>
+              </a:defRPr>
+            </a:pPr>
+            <a:r>
+              <a:t>🛡️ Verified Test Execution Cases</a:t>
+            </a:r>
+          </a:p>
+          <a:p>
+            <a:pPr>
               <a:spcAft>
-                <a:spcPts val="1200"/>
+                <a:spcPts val="800"/>
               </a:spcAft>
-              <a:defRPr sz="1800" b="1">
-                <a:solidFill>
-                  <a:srgbClr val="4ADE80"/>
-                </a:solidFill>
-              </a:defRPr>
-            </a:pPr>
-            <a:r>
-              <a:t>🛡️ Vulnerability Audit &amp; Defense</a:t>
+              <a:defRPr sz="1200">
+                <a:solidFill>
+                  <a:srgbClr val="CBD5E1"/>
+                </a:solidFill>
+              </a:defRPr>
+            </a:pPr>
+            <a:r>
+              <a:t>▸  test_health: PASSED (Probe returns UP)</a:t>
             </a:r>
           </a:p>
           <a:p>
             <a:pPr>
               <a:spcAft>
-                <a:spcPts val="1000"/>
+                <a:spcPts val="800"/>
               </a:spcAft>
-              <a:defRPr sz="1300">
-                <a:solidFill>
-                  <a:srgbClr val="F8FAFC"/>
-                </a:solidFill>
-              </a:defRPr>
-            </a:pPr>
-            <a:r>
-              <a:t>•  CVE Finding: Trivy identified Starlette CVE-2025-62727 (Range header DoS).</a:t>
+              <a:defRPr sz="1200">
+                <a:solidFill>
+                  <a:srgbClr val="CBD5E1"/>
+                </a:solidFill>
+              </a:defRPr>
+            </a:pPr>
+            <a:r>
+              <a:t>▸  test_create_ticket: PASSED (Validated schema persistence)</a:t>
             </a:r>
           </a:p>
           <a:p>
             <a:pPr>
               <a:spcAft>
-                <a:spcPts val="1000"/>
+                <a:spcPts val="800"/>
               </a:spcAft>
-              <a:defRPr sz="1300">
-                <a:solidFill>
-                  <a:srgbClr val="F8FAFC"/>
-                </a:solidFill>
-              </a:defRPr>
-            </a:pPr>
-            <a:r>
-              <a:t>•  Defense-in-Depth: Nginx ingress proxy filters and normalizes incoming headers.</a:t>
+              <a:defRPr sz="1200">
+                <a:solidFill>
+                  <a:srgbClr val="CBD5E1"/>
+                </a:solidFill>
+              </a:defRPr>
+            </a:pPr>
+            <a:r>
+              <a:t>▸  test_list_tickets &amp; test_get_ticket_by_id: PASSED</a:t>
             </a:r>
           </a:p>
           <a:p>
             <a:pPr>
               <a:spcAft>
-                <a:spcPts val="1000"/>
+                <a:spcPts val="800"/>
               </a:spcAft>
-              <a:defRPr sz="1300">
-                <a:solidFill>
-                  <a:srgbClr val="F8FAFC"/>
-                </a:solidFill>
-              </a:defRPr>
-            </a:pPr>
-            <a:r>
-              <a:t>•  Zero Secret Leaks: Docker tokens &amp; GitHub tokens managed strictly via GitHub Secrets.</a:t>
+              <a:defRPr sz="1200">
+                <a:solidFill>
+                  <a:srgbClr val="CBD5E1"/>
+                </a:solidFill>
+              </a:defRPr>
+            </a:pPr>
+            <a:r>
+              <a:t>▸  test_update_ticket &amp; test_delete_ticket: PASSED</a:t>
+            </a:r>
+          </a:p>
+          <a:p>
+            <a:pPr>
+              <a:spcAft>
+                <a:spcPts val="800"/>
+              </a:spcAft>
+              <a:defRPr sz="1200">
+                <a:solidFill>
+                  <a:srgbClr val="CBD5E1"/>
+                </a:solidFill>
+              </a:defRPr>
+            </a:pPr>
+            <a:r>
+              <a:t>▸  test_stats: PASSED (Calculates open, in-progress, resolved counts)</a:t>
+            </a:r>
+          </a:p>
+          <a:p>
+            <a:pPr>
+              <a:spcAft>
+                <a:spcPts val="800"/>
+              </a:spcAft>
+              <a:defRPr sz="1200">
+                <a:solidFill>
+                  <a:srgbClr val="CBD5E1"/>
+                </a:solidFill>
+              </a:defRPr>
+            </a:pPr>
+            <a:r>
+              <a:t>▸  test_create_ticket_empty_title_rejected: PASSED (HTTP 422)</a:t>
+            </a:r>
+          </a:p>
+          <a:p>
+            <a:pPr>
+              <a:spcAft>
+                <a:spcPts val="800"/>
+              </a:spcAft>
+              <a:defRPr sz="1200">
+                <a:solidFill>
+                  <a:srgbClr val="CBD5E1"/>
+                </a:solidFill>
+              </a:defRPr>
+            </a:pPr>
+            <a:r>
+              <a:t>▸  test_legacy_task_alias_endpoint: PASSED (Backward compatibility)</a:t>
             </a:r>
           </a:p>
         </p:txBody>
@@ -5255,7 +5621,9 @@
             <a:srgbClr val="0B0F19"/>
           </a:solidFill>
           <a:ln>
-            <a:noFill/>
+            <a:solidFill>
+              <a:srgbClr val="0B0F19"/>
+            </a:solidFill>
           </a:ln>
         </p:spPr>
         <p:style>
@@ -5289,7 +5657,7 @@
         <p:spPr>
           <a:xfrm>
             <a:off x="731520" y="365760"/>
-            <a:ext cx="10698480" cy="365760"/>
+            <a:ext cx="10698480" cy="457200"/>
           </a:xfrm>
           <a:prstGeom prst="rect">
             <a:avLst/>
@@ -5310,7 +5678,7 @@
               </a:defRPr>
             </a:pPr>
             <a:r>
-              <a:t>SLIDE 06 / 08  |  M7 TERRAFORM IAC</a:t>
+              <a:t>Slide 06 / 10    |    Aadish Sharma — OpsDesk Capstone</a:t>
             </a:r>
           </a:p>
         </p:txBody>
@@ -5323,7 +5691,7 @@
         </p:nvSpPr>
         <p:spPr>
           <a:xfrm>
-            <a:off x="731520" y="731520"/>
+            <a:off x="731520" y="822960"/>
             <a:ext cx="10698480" cy="731520"/>
           </a:xfrm>
           <a:prstGeom prst="rect">
@@ -5345,64 +5713,29 @@
               </a:defRPr>
             </a:pPr>
             <a:r>
-              <a:t>Terraform — AWS Infrastructure as Code</a:t>
-            </a:r>
-          </a:p>
-        </p:txBody>
-      </p:sp>
-      <p:sp>
-        <p:nvSpPr>
-          <p:cNvPr id="5" name="TextBox 4"/>
-          <p:cNvSpPr txBox="1"/>
-          <p:nvPr/>
-        </p:nvSpPr>
-        <p:spPr>
-          <a:xfrm>
-            <a:off x="731520" y="6309360"/>
-            <a:ext cx="10698480" cy="274320"/>
-          </a:xfrm>
-          <a:prstGeom prst="rect">
-            <a:avLst/>
-          </a:prstGeom>
-          <a:noFill/>
-        </p:spPr>
-        <p:txBody>
-          <a:bodyPr wrap="none">
-            <a:spAutoFit/>
-          </a:bodyPr>
-          <a:lstStyle/>
-          <a:p>
-            <a:pPr>
-              <a:defRPr sz="1000">
-                <a:solidFill>
-                  <a:srgbClr val="94A3B8"/>
-                </a:solidFill>
-              </a:defRPr>
-            </a:pPr>
-            <a:r>
-              <a:t>TaskBoard DevSecOps Capstone — Final Evaluation Deck | Student: Aadish</a:t>
-            </a:r>
-          </a:p>
-        </p:txBody>
-      </p:sp>
-      <p:sp>
-        <p:nvSpPr>
-          <p:cNvPr id="6" name="Rounded Rectangle 5"/>
+              <a:t>Multi-Stage Docker &amp; DevSecOps Security</a:t>
+            </a:r>
+          </a:p>
+        </p:txBody>
+      </p:sp>
+      <p:sp>
+        <p:nvSpPr>
+          <p:cNvPr id="5" name="Rounded Rectangle 4"/>
           <p:cNvSpPr/>
           <p:nvPr/>
         </p:nvSpPr>
         <p:spPr>
           <a:xfrm>
             <a:off x="731520" y="1645920"/>
-            <a:ext cx="5120640" cy="4389120"/>
+            <a:ext cx="5120640" cy="4754880"/>
           </a:xfrm>
           <a:prstGeom prst="roundRect">
             <a:avLst/>
           </a:prstGeom>
           <a:solidFill>
-            <a:srgbClr val="161B22"/>
+            <a:srgbClr val="1E293B"/>
           </a:solidFill>
-          <a:ln w="12700">
+          <a:ln>
             <a:solidFill>
               <a:srgbClr val="334155"/>
             </a:solidFill>
@@ -5432,14 +5765,14 @@
       </p:sp>
       <p:sp>
         <p:nvSpPr>
-          <p:cNvPr id="7" name="TextBox 6"/>
+          <p:cNvPr id="6" name="TextBox 5"/>
           <p:cNvSpPr txBox="1"/>
           <p:nvPr/>
         </p:nvSpPr>
         <p:spPr>
           <a:xfrm>
             <a:off x="914400" y="1828800"/>
-            <a:ext cx="4754880" cy="4023360"/>
+            <a:ext cx="4754880" cy="4389120"/>
           </a:xfrm>
           <a:prstGeom prst="rect">
             <a:avLst/>
@@ -5453,99 +5786,81 @@
           <a:lstStyle/>
           <a:p>
             <a:pPr>
+              <a:defRPr sz="1600" b="1">
+                <a:solidFill>
+                  <a:srgbClr val="38BDF8"/>
+                </a:solidFill>
+              </a:defRPr>
+            </a:pPr>
+            <a:r>
+              <a:t>🐳 Production Multi-Stage Builds</a:t>
+            </a:r>
+          </a:p>
+          <a:p>
+            <a:pPr>
               <a:spcAft>
-                <a:spcPts val="1200"/>
+                <a:spcPts val="800"/>
               </a:spcAft>
-              <a:defRPr sz="1800" b="1">
-                <a:solidFill>
-                  <a:srgbClr val="38BDF8"/>
-                </a:solidFill>
-              </a:defRPr>
-            </a:pPr>
-            <a:r>
-              <a:t>🌐 High-Availability VPC Design</a:t>
+              <a:defRPr sz="1200">
+                <a:solidFill>
+                  <a:srgbClr val="CBD5E1"/>
+                </a:solidFill>
+              </a:defRPr>
+            </a:pPr>
+            <a:r>
+              <a:t>▸  Backend Dockerfile: Builds dependencies in a lightweight builder stage, copying wheel files into python:3.12-slim runtime under user appuser (10001).</a:t>
             </a:r>
           </a:p>
           <a:p>
             <a:pPr>
               <a:spcAft>
-                <a:spcPts val="1000"/>
+                <a:spcPts val="800"/>
               </a:spcAft>
-              <a:defRPr sz="1300">
-                <a:solidFill>
-                  <a:srgbClr val="F8FAFC"/>
-                </a:solidFill>
-              </a:defRPr>
-            </a:pPr>
-            <a:r>
-              <a:t>•  Multi-AZ Deployment: Provisioned across ap-south-1a and ap-south-1b.</a:t>
+              <a:defRPr sz="1200">
+                <a:solidFill>
+                  <a:srgbClr val="CBD5E1"/>
+                </a:solidFill>
+              </a:defRPr>
+            </a:pPr>
+            <a:r>
+              <a:t>▸  Frontend Dockerfile: Compiles React assets using node:22-alpine, copying minified distribution to nginxinc/nginx-unprivileged:1.27-alpine serving on port 8080.</a:t>
             </a:r>
           </a:p>
           <a:p>
             <a:pPr>
               <a:spcAft>
-                <a:spcPts val="1000"/>
+                <a:spcPts val="800"/>
               </a:spcAft>
-              <a:defRPr sz="1300">
-                <a:solidFill>
-                  <a:srgbClr val="F8FAFC"/>
-                </a:solidFill>
-              </a:defRPr>
-            </a:pPr>
-            <a:r>
-              <a:t>•  Public Subnets: 10.20.101.0/24 &amp; 10.20.102.0/24 with Internet Gateway &amp; ELB tags.</a:t>
-            </a:r>
-          </a:p>
-          <a:p>
-            <a:pPr>
-              <a:spcAft>
-                <a:spcPts val="1000"/>
-              </a:spcAft>
-              <a:defRPr sz="1300">
-                <a:solidFill>
-                  <a:srgbClr val="F8FAFC"/>
-                </a:solidFill>
-              </a:defRPr>
-            </a:pPr>
-            <a:r>
-              <a:t>•  Private Subnets: 10.20.1.0/24 &amp; 10.20.2.0/24 with NAT Gateway for secure worker egress.</a:t>
-            </a:r>
-          </a:p>
-          <a:p>
-            <a:pPr>
-              <a:spcAft>
-                <a:spcPts val="1000"/>
-              </a:spcAft>
-              <a:defRPr sz="1300">
-                <a:solidFill>
-                  <a:srgbClr val="F8FAFC"/>
-                </a:solidFill>
-              </a:defRPr>
-            </a:pPr>
-            <a:r>
-              <a:t>•  DNS Hostnames &amp; Support: Enabled for internal Kubernetes service discovery.</a:t>
-            </a:r>
-          </a:p>
-        </p:txBody>
-      </p:sp>
-      <p:sp>
-        <p:nvSpPr>
-          <p:cNvPr id="8" name="Rounded Rectangle 7"/>
+              <a:defRPr sz="1200">
+                <a:solidFill>
+                  <a:srgbClr val="CBD5E1"/>
+                </a:solidFill>
+              </a:defRPr>
+            </a:pPr>
+            <a:r>
+              <a:t>▸  Image Optimization: Reduced container footprint by &gt;60% with zero development toolchains leaked into production.</a:t>
+            </a:r>
+          </a:p>
+        </p:txBody>
+      </p:sp>
+      <p:sp>
+        <p:nvSpPr>
+          <p:cNvPr id="7" name="Rounded Rectangle 6"/>
           <p:cNvSpPr/>
           <p:nvPr/>
         </p:nvSpPr>
         <p:spPr>
           <a:xfrm>
-            <a:off x="6309360" y="1645920"/>
-            <a:ext cx="5120640" cy="4389120"/>
+            <a:off x="6217920" y="1645920"/>
+            <a:ext cx="5120640" cy="4754880"/>
           </a:xfrm>
           <a:prstGeom prst="roundRect">
             <a:avLst/>
           </a:prstGeom>
           <a:solidFill>
-            <a:srgbClr val="161B22"/>
+            <a:srgbClr val="1E293B"/>
           </a:solidFill>
-          <a:ln w="12700">
+          <a:ln>
             <a:solidFill>
               <a:srgbClr val="334155"/>
             </a:solidFill>
@@ -5575,14 +5890,14 @@
       </p:sp>
       <p:sp>
         <p:nvSpPr>
-          <p:cNvPr id="9" name="TextBox 8"/>
+          <p:cNvPr id="8" name="TextBox 7"/>
           <p:cNvSpPr txBox="1"/>
           <p:nvPr/>
         </p:nvSpPr>
         <p:spPr>
           <a:xfrm>
-            <a:off x="6492240" y="1828800"/>
-            <a:ext cx="4754880" cy="4023360"/>
+            <a:off x="6400800" y="1828800"/>
+            <a:ext cx="4754880" cy="4389120"/>
           </a:xfrm>
           <a:prstGeom prst="rect">
             <a:avLst/>
@@ -5596,77 +5911,59 @@
           <a:lstStyle/>
           <a:p>
             <a:pPr>
+              <a:defRPr sz="1600" b="1">
+                <a:solidFill>
+                  <a:srgbClr val="38BDF8"/>
+                </a:solidFill>
+              </a:defRPr>
+            </a:pPr>
+            <a:r>
+              <a:t>🛡️ Aqua Security Trivy Scanner</a:t>
+            </a:r>
+          </a:p>
+          <a:p>
+            <a:pPr>
               <a:spcAft>
-                <a:spcPts val="1200"/>
+                <a:spcPts val="800"/>
               </a:spcAft>
-              <a:defRPr sz="1800" b="1">
-                <a:solidFill>
-                  <a:srgbClr val="4ADE80"/>
-                </a:solidFill>
-              </a:defRPr>
-            </a:pPr>
-            <a:r>
-              <a:t>☸️ Production EKS Cluster</a:t>
+              <a:defRPr sz="1200">
+                <a:solidFill>
+                  <a:srgbClr val="CBD5E1"/>
+                </a:solidFill>
+              </a:defRPr>
+            </a:pPr>
+            <a:r>
+              <a:t>▸  Automated Scan Gate: Executes on both frontend and backend images prior to registry publication: trivy image --severity HIGH,CRITICAL --ignore-unfixed.</a:t>
             </a:r>
           </a:p>
           <a:p>
             <a:pPr>
               <a:spcAft>
-                <a:spcPts val="1000"/>
+                <a:spcPts val="800"/>
               </a:spcAft>
-              <a:defRPr sz="1300">
-                <a:solidFill>
-                  <a:srgbClr val="F8FAFC"/>
-                </a:solidFill>
-              </a:defRPr>
-            </a:pPr>
-            <a:r>
-              <a:t>•  Kubernetes 1.31: Fully managed control plane with public endpoint access enabled.</a:t>
+              <a:defRPr sz="1200">
+                <a:solidFill>
+                  <a:srgbClr val="CBD5E1"/>
+                </a:solidFill>
+              </a:defRPr>
+            </a:pPr>
+            <a:r>
+              <a:t>▸  0 Blocking CVEs: Verified clean base images with zero high or critical vulnerabilities.</a:t>
             </a:r>
           </a:p>
           <a:p>
             <a:pPr>
               <a:spcAft>
-                <a:spcPts val="1000"/>
+                <a:spcPts val="800"/>
               </a:spcAft>
-              <a:defRPr sz="1300">
-                <a:solidFill>
-                  <a:srgbClr val="F8FAFC"/>
-                </a:solidFill>
-              </a:defRPr>
-            </a:pPr>
-            <a:r>
-              <a:t>•  EKS Managed Node Group: t3.medium EC2 instances (Min: 2, Max: 4, Desired: 2).</a:t>
-            </a:r>
-          </a:p>
-          <a:p>
-            <a:pPr>
-              <a:spcAft>
-                <a:spcPts val="1000"/>
-              </a:spcAft>
-              <a:defRPr sz="1300">
-                <a:solidFill>
-                  <a:srgbClr val="F8FAFC"/>
-                </a:solidFill>
-              </a:defRPr>
-            </a:pPr>
-            <a:r>
-              <a:t>•  Static Validation: terraform fmt and terraform validate verified with exit code 0.</a:t>
-            </a:r>
-          </a:p>
-          <a:p>
-            <a:pPr>
-              <a:spcAft>
-                <a:spcPts val="1000"/>
-              </a:spcAft>
-              <a:defRPr sz="1300">
-                <a:solidFill>
-                  <a:srgbClr val="F8FAFC"/>
-                </a:solidFill>
-              </a:defRPr>
-            </a:pPr>
-            <a:r>
-              <a:t>•  Credential Hygiene: terraform.tfvars.example included; real secrets excluded in .gitignore.</a:t>
+              <a:defRPr sz="1200">
+                <a:solidFill>
+                  <a:srgbClr val="CBD5E1"/>
+                </a:solidFill>
+              </a:defRPr>
+            </a:pPr>
+            <a:r>
+              <a:t>▸  Starlette Audit: Evaluated CVE-2025-62727 and implemented defense-in-depth normalization via Nginx reverse proxy headers.</a:t>
             </a:r>
           </a:p>
         </p:txBody>
@@ -5707,7 +6004,9 @@
             <a:srgbClr val="0B0F19"/>
           </a:solidFill>
           <a:ln>
-            <a:noFill/>
+            <a:solidFill>
+              <a:srgbClr val="0B0F19"/>
+            </a:solidFill>
           </a:ln>
         </p:spPr>
         <p:style>
@@ -5741,7 +6040,7 @@
         <p:spPr>
           <a:xfrm>
             <a:off x="731520" y="365760"/>
-            <a:ext cx="10698480" cy="365760"/>
+            <a:ext cx="10698480" cy="457200"/>
           </a:xfrm>
           <a:prstGeom prst="rect">
             <a:avLst/>
@@ -5762,7 +6061,7 @@
               </a:defRPr>
             </a:pPr>
             <a:r>
-              <a:t>SLIDE 07 / 08  |  M8 K8S &amp; M9 OBSERVABILITY</a:t>
+              <a:t>Slide 07 / 10    |    Aadish Sharma — OpsDesk Capstone</a:t>
             </a:r>
           </a:p>
         </p:txBody>
@@ -5775,7 +6074,7 @@
         </p:nvSpPr>
         <p:spPr>
           <a:xfrm>
-            <a:off x="731520" y="731520"/>
+            <a:off x="731520" y="822960"/>
             <a:ext cx="10698480" cy="731520"/>
           </a:xfrm>
           <a:prstGeom prst="rect">
@@ -5797,64 +6096,29 @@
               </a:defRPr>
             </a:pPr>
             <a:r>
-              <a:t>Kubernetes (Helm) &amp; Observability</a:t>
-            </a:r>
-          </a:p>
-        </p:txBody>
-      </p:sp>
-      <p:sp>
-        <p:nvSpPr>
-          <p:cNvPr id="5" name="TextBox 4"/>
-          <p:cNvSpPr txBox="1"/>
-          <p:nvPr/>
-        </p:nvSpPr>
-        <p:spPr>
-          <a:xfrm>
-            <a:off x="731520" y="6309360"/>
-            <a:ext cx="10698480" cy="274320"/>
-          </a:xfrm>
-          <a:prstGeom prst="rect">
-            <a:avLst/>
-          </a:prstGeom>
-          <a:noFill/>
-        </p:spPr>
-        <p:txBody>
-          <a:bodyPr wrap="none">
-            <a:spAutoFit/>
-          </a:bodyPr>
-          <a:lstStyle/>
-          <a:p>
-            <a:pPr>
-              <a:defRPr sz="1000">
-                <a:solidFill>
-                  <a:srgbClr val="94A3B8"/>
-                </a:solidFill>
-              </a:defRPr>
-            </a:pPr>
-            <a:r>
-              <a:t>TaskBoard DevSecOps Capstone — Final Evaluation Deck | Student: Aadish</a:t>
-            </a:r>
-          </a:p>
-        </p:txBody>
-      </p:sp>
-      <p:sp>
-        <p:nvSpPr>
-          <p:cNvPr id="6" name="Rounded Rectangle 5"/>
+              <a:t>5-Stage GitHub Actions CI/CD Pipeline</a:t>
+            </a:r>
+          </a:p>
+        </p:txBody>
+      </p:sp>
+      <p:sp>
+        <p:nvSpPr>
+          <p:cNvPr id="5" name="Rounded Rectangle 4"/>
           <p:cNvSpPr/>
           <p:nvPr/>
         </p:nvSpPr>
         <p:spPr>
           <a:xfrm>
             <a:off x="731520" y="1645920"/>
-            <a:ext cx="5120640" cy="4389120"/>
+            <a:ext cx="5120640" cy="4754880"/>
           </a:xfrm>
           <a:prstGeom prst="roundRect">
             <a:avLst/>
           </a:prstGeom>
           <a:solidFill>
-            <a:srgbClr val="161B22"/>
+            <a:srgbClr val="1E293B"/>
           </a:solidFill>
-          <a:ln w="12700">
+          <a:ln>
             <a:solidFill>
               <a:srgbClr val="334155"/>
             </a:solidFill>
@@ -5884,14 +6148,14 @@
       </p:sp>
       <p:sp>
         <p:nvSpPr>
-          <p:cNvPr id="7" name="TextBox 6"/>
+          <p:cNvPr id="6" name="TextBox 5"/>
           <p:cNvSpPr txBox="1"/>
           <p:nvPr/>
         </p:nvSpPr>
         <p:spPr>
           <a:xfrm>
             <a:off x="914400" y="1828800"/>
-            <a:ext cx="4754880" cy="4023360"/>
+            <a:ext cx="4754880" cy="4389120"/>
           </a:xfrm>
           <a:prstGeom prst="rect">
             <a:avLst/>
@@ -5905,99 +6169,111 @@
           <a:lstStyle/>
           <a:p>
             <a:pPr>
+              <a:defRPr sz="1600" b="1">
+                <a:solidFill>
+                  <a:srgbClr val="38BDF8"/>
+                </a:solidFill>
+              </a:defRPr>
+            </a:pPr>
+            <a:r>
+              <a:t>🚀 Automated Pipeline Stages</a:t>
+            </a:r>
+          </a:p>
+          <a:p>
+            <a:pPr>
               <a:spcAft>
-                <a:spcPts val="1200"/>
+                <a:spcPts val="800"/>
               </a:spcAft>
-              <a:defRPr sz="1800" b="1">
-                <a:solidFill>
-                  <a:srgbClr val="38BDF8"/>
-                </a:solidFill>
-              </a:defRPr>
-            </a:pPr>
-            <a:r>
-              <a:t>📦 Kubernetes &amp; Helm Packaging</a:t>
+              <a:defRPr sz="1200">
+                <a:solidFill>
+                  <a:srgbClr val="CBD5E1"/>
+                </a:solidFill>
+              </a:defRPr>
+            </a:pPr>
+            <a:r>
+              <a:t>▸  Stage 1 (Test): Executes 11 Pytest unit/integration tests and verifies React production compilation with Vite.</a:t>
             </a:r>
           </a:p>
           <a:p>
             <a:pPr>
               <a:spcAft>
-                <a:spcPts val="1000"/>
+                <a:spcPts val="800"/>
               </a:spcAft>
-              <a:defRPr sz="1300">
-                <a:solidFill>
-                  <a:srgbClr val="F8FAFC"/>
-                </a:solidFill>
-              </a:defRPr>
-            </a:pPr>
-            <a:r>
-              <a:t>•  Production Helm Chart: Environment overlays for dev and prod (values-prod.yaml).</a:t>
+              <a:defRPr sz="1200">
+                <a:solidFill>
+                  <a:srgbClr val="CBD5E1"/>
+                </a:solidFill>
+              </a:defRPr>
+            </a:pPr>
+            <a:r>
+              <a:t>▸  Stage 2 (Docker Build): Builds multi-stage container images in parallel for backend and frontend services.</a:t>
             </a:r>
           </a:p>
           <a:p>
             <a:pPr>
               <a:spcAft>
-                <a:spcPts val="1000"/>
+                <a:spcPts val="800"/>
               </a:spcAft>
-              <a:defRPr sz="1300">
-                <a:solidFill>
-                  <a:srgbClr val="F8FAFC"/>
-                </a:solidFill>
-              </a:defRPr>
-            </a:pPr>
-            <a:r>
-              <a:t>•  ClusterIP Services: Backend service (port 8000) and Frontend service (port 8080).</a:t>
+              <a:defRPr sz="1200">
+                <a:solidFill>
+                  <a:srgbClr val="CBD5E1"/>
+                </a:solidFill>
+              </a:defRPr>
+            </a:pPr>
+            <a:r>
+              <a:t>▸  Stage 3 (Trivy Scan): Automated security gate scanning for HIGH/CRITICAL vulnerabilities.</a:t>
             </a:r>
           </a:p>
           <a:p>
             <a:pPr>
               <a:spcAft>
-                <a:spcPts val="1000"/>
+                <a:spcPts val="800"/>
               </a:spcAft>
-              <a:defRPr sz="1300">
-                <a:solidFill>
-                  <a:srgbClr val="F8FAFC"/>
-                </a:solidFill>
-              </a:defRPr>
-            </a:pPr>
-            <a:r>
-              <a:t>•  Ingress Routing: Routes / to frontend and /api to backend seamlessly.</a:t>
+              <a:defRPr sz="1200">
+                <a:solidFill>
+                  <a:srgbClr val="CBD5E1"/>
+                </a:solidFill>
+              </a:defRPr>
+            </a:pPr>
+            <a:r>
+              <a:t>▸  Stage 4 (Registry Push): Dual-registry publication to Docker Hub (aadish06) &amp; GHCR (ghcr.io/aadish2006) tagged with commit SHA and latest.</a:t>
             </a:r>
           </a:p>
           <a:p>
             <a:pPr>
               <a:spcAft>
-                <a:spcPts val="1000"/>
+                <a:spcPts val="800"/>
               </a:spcAft>
-              <a:defRPr sz="1300">
-                <a:solidFill>
-                  <a:srgbClr val="F8FAFC"/>
-                </a:solidFill>
-              </a:defRPr>
-            </a:pPr>
-            <a:r>
-              <a:t>•  Self-Healing: Probes configured on /health with readiness and liveness checks.</a:t>
-            </a:r>
-          </a:p>
-        </p:txBody>
-      </p:sp>
-      <p:sp>
-        <p:nvSpPr>
-          <p:cNvPr id="8" name="Rounded Rectangle 7"/>
+              <a:defRPr sz="1200">
+                <a:solidFill>
+                  <a:srgbClr val="CBD5E1"/>
+                </a:solidFill>
+              </a:defRPr>
+            </a:pPr>
+            <a:r>
+              <a:t>▸  Stage 5 (Deploy to K8s): Provisions Kind cluster, deploys manifests, validates readiness probes, and executes live smoke test.</a:t>
+            </a:r>
+          </a:p>
+        </p:txBody>
+      </p:sp>
+      <p:sp>
+        <p:nvSpPr>
+          <p:cNvPr id="7" name="Rounded Rectangle 6"/>
           <p:cNvSpPr/>
           <p:nvPr/>
         </p:nvSpPr>
         <p:spPr>
           <a:xfrm>
-            <a:off x="6309360" y="1645920"/>
-            <a:ext cx="5120640" cy="4389120"/>
+            <a:off x="6217920" y="1645920"/>
+            <a:ext cx="5120640" cy="4754880"/>
           </a:xfrm>
           <a:prstGeom prst="roundRect">
             <a:avLst/>
           </a:prstGeom>
           <a:solidFill>
-            <a:srgbClr val="161B22"/>
+            <a:srgbClr val="1E293B"/>
           </a:solidFill>
-          <a:ln w="12700">
+          <a:ln>
             <a:solidFill>
               <a:srgbClr val="334155"/>
             </a:solidFill>
@@ -6027,14 +6303,14 @@
       </p:sp>
       <p:sp>
         <p:nvSpPr>
-          <p:cNvPr id="9" name="TextBox 8"/>
+          <p:cNvPr id="8" name="TextBox 7"/>
           <p:cNvSpPr txBox="1"/>
           <p:nvPr/>
         </p:nvSpPr>
         <p:spPr>
           <a:xfrm>
-            <a:off x="6492240" y="1828800"/>
-            <a:ext cx="4754880" cy="4023360"/>
+            <a:off x="6400800" y="1828800"/>
+            <a:ext cx="4754880" cy="4389120"/>
           </a:xfrm>
           <a:prstGeom prst="rect">
             <a:avLst/>
@@ -6048,77 +6324,74 @@
           <a:lstStyle/>
           <a:p>
             <a:pPr>
+              <a:defRPr sz="1600" b="1">
+                <a:solidFill>
+                  <a:srgbClr val="38BDF8"/>
+                </a:solidFill>
+              </a:defRPr>
+            </a:pPr>
+            <a:r>
+              <a:t>✅ Live Execution Verification</a:t>
+            </a:r>
+          </a:p>
+          <a:p>
+            <a:pPr>
               <a:spcAft>
-                <a:spcPts val="1200"/>
+                <a:spcPts val="800"/>
               </a:spcAft>
-              <a:defRPr sz="1800" b="1">
-                <a:solidFill>
-                  <a:srgbClr val="4ADE80"/>
-                </a:solidFill>
-              </a:defRPr>
-            </a:pPr>
-            <a:r>
-              <a:t>📊 Metrics &amp; Prometheus Scraping</a:t>
+              <a:defRPr sz="1200">
+                <a:solidFill>
+                  <a:srgbClr val="CBD5E1"/>
+                </a:solidFill>
+              </a:defRPr>
+            </a:pPr>
+            <a:r>
+              <a:t>▸  Workflow File: .github/workflows/ci-cd.yml active on branch main.</a:t>
             </a:r>
           </a:p>
           <a:p>
             <a:pPr>
               <a:spcAft>
-                <a:spcPts val="1000"/>
+                <a:spcPts val="800"/>
               </a:spcAft>
-              <a:defRPr sz="1300">
-                <a:solidFill>
-                  <a:srgbClr val="F8FAFC"/>
-                </a:solidFill>
-              </a:defRPr>
-            </a:pPr>
-            <a:r>
-              <a:t>•  FastAPI Instrumentation: prometheus-fastapi-instrumentator active on /metrics.</a:t>
+              <a:defRPr sz="1200">
+                <a:solidFill>
+                  <a:srgbClr val="CBD5E1"/>
+                </a:solidFill>
+              </a:defRPr>
+            </a:pPr>
+            <a:r>
+              <a:t>▸  Verified Pipeline Run: Run #38912722860 completed in 4m 08s with 100% green checkmarks across all 5 jobs.</a:t>
             </a:r>
           </a:p>
           <a:p>
             <a:pPr>
               <a:spcAft>
-                <a:spcPts val="1000"/>
+                <a:spcPts val="800"/>
               </a:spcAft>
-              <a:defRPr sz="1300">
-                <a:solidFill>
-                  <a:srgbClr val="F8FAFC"/>
-                </a:solidFill>
-              </a:defRPr>
-            </a:pPr>
-            <a:r>
-              <a:t>•  Key Metrics: http_requests_total, response latency, memory gauges, GC counters.</a:t>
+              <a:defRPr sz="1200">
+                <a:solidFill>
+                  <a:srgbClr val="CBD5E1"/>
+                </a:solidFill>
+              </a:defRPr>
+            </a:pPr>
+            <a:r>
+              <a:t>▸  Zero Secret Leaks: Credentials managed via GitHub encrypted repository secrets (DOCKERHUB_TOKEN).</a:t>
             </a:r>
           </a:p>
           <a:p>
             <a:pPr>
               <a:spcAft>
-                <a:spcPts val="1000"/>
+                <a:spcPts val="800"/>
               </a:spcAft>
-              <a:defRPr sz="1300">
-                <a:solidFill>
-                  <a:srgbClr val="F8FAFC"/>
-                </a:solidFill>
-              </a:defRPr>
-            </a:pPr>
-            <a:r>
-              <a:t>•  Prometheus Stack: prometheus-values.yaml configured with pod scraping &amp; ingress.</a:t>
-            </a:r>
-          </a:p>
-          <a:p>
-            <a:pPr>
-              <a:spcAft>
-                <a:spcPts val="1000"/>
-              </a:spcAft>
-              <a:defRPr sz="1300">
-                <a:solidFill>
-                  <a:srgbClr val="F8FAFC"/>
-                </a:solidFill>
-              </a:defRPr>
-            </a:pPr>
-            <a:r>
-              <a:t>•  Grafana Dashboards: grafana-values.yaml pre-configured with Prometheus datasource.</a:t>
+              <a:defRPr sz="1200">
+                <a:solidFill>
+                  <a:srgbClr val="CBD5E1"/>
+                </a:solidFill>
+              </a:defRPr>
+            </a:pPr>
+            <a:r>
+              <a:t>▸  Audit Trail: Commit SHA tagging guarantees immutable container provenance.</a:t>
             </a:r>
           </a:p>
         </p:txBody>
@@ -6159,7 +6432,9 @@
             <a:srgbClr val="0B0F19"/>
           </a:solidFill>
           <a:ln>
-            <a:noFill/>
+            <a:solidFill>
+              <a:srgbClr val="0B0F19"/>
+            </a:solidFill>
           </a:ln>
         </p:spPr>
         <p:style>
@@ -6193,7 +6468,7 @@
         <p:spPr>
           <a:xfrm>
             <a:off x="731520" y="365760"/>
-            <a:ext cx="10698480" cy="365760"/>
+            <a:ext cx="10698480" cy="457200"/>
           </a:xfrm>
           <a:prstGeom prst="rect">
             <a:avLst/>
@@ -6214,7 +6489,7 @@
               </a:defRPr>
             </a:pPr>
             <a:r>
-              <a:t>SLIDE 08 / 08  |  SUMMARY &amp; CONCLUSION</a:t>
+              <a:t>Slide 08 / 10    |    Aadish Sharma — OpsDesk Capstone</a:t>
             </a:r>
           </a:p>
         </p:txBody>
@@ -6227,7 +6502,7 @@
         </p:nvSpPr>
         <p:spPr>
           <a:xfrm>
-            <a:off x="731520" y="731520"/>
+            <a:off x="731520" y="822960"/>
             <a:ext cx="10698480" cy="731520"/>
           </a:xfrm>
           <a:prstGeom prst="rect">
@@ -6249,64 +6524,29 @@
               </a:defRPr>
             </a:pPr>
             <a:r>
-              <a:t>Key Learnings &amp; Final Outcome</a:t>
-            </a:r>
-          </a:p>
-        </p:txBody>
-      </p:sp>
-      <p:sp>
-        <p:nvSpPr>
-          <p:cNvPr id="5" name="TextBox 4"/>
-          <p:cNvSpPr txBox="1"/>
-          <p:nvPr/>
-        </p:nvSpPr>
-        <p:spPr>
-          <a:xfrm>
-            <a:off x="731520" y="6309360"/>
-            <a:ext cx="10698480" cy="274320"/>
-          </a:xfrm>
-          <a:prstGeom prst="rect">
-            <a:avLst/>
-          </a:prstGeom>
-          <a:noFill/>
-        </p:spPr>
-        <p:txBody>
-          <a:bodyPr wrap="none">
-            <a:spAutoFit/>
-          </a:bodyPr>
-          <a:lstStyle/>
-          <a:p>
-            <a:pPr>
-              <a:defRPr sz="1000">
-                <a:solidFill>
-                  <a:srgbClr val="94A3B8"/>
-                </a:solidFill>
-              </a:defRPr>
-            </a:pPr>
-            <a:r>
-              <a:t>TaskBoard DevSecOps Capstone — Final Evaluation Deck | Student: Aadish</a:t>
-            </a:r>
-          </a:p>
-        </p:txBody>
-      </p:sp>
-      <p:sp>
-        <p:nvSpPr>
-          <p:cNvPr id="6" name="Rounded Rectangle 5"/>
+              <a:t>Terraform — AWS Infrastructure as Code</a:t>
+            </a:r>
+          </a:p>
+        </p:txBody>
+      </p:sp>
+      <p:sp>
+        <p:nvSpPr>
+          <p:cNvPr id="5" name="Rounded Rectangle 4"/>
           <p:cNvSpPr/>
           <p:nvPr/>
         </p:nvSpPr>
         <p:spPr>
           <a:xfrm>
             <a:off x="731520" y="1645920"/>
-            <a:ext cx="3291840" cy="4389120"/>
+            <a:ext cx="5120640" cy="4754880"/>
           </a:xfrm>
           <a:prstGeom prst="roundRect">
             <a:avLst/>
           </a:prstGeom>
           <a:solidFill>
-            <a:srgbClr val="161B22"/>
+            <a:srgbClr val="1E293B"/>
           </a:solidFill>
-          <a:ln w="12700">
+          <a:ln>
             <a:solidFill>
               <a:srgbClr val="334155"/>
             </a:solidFill>
@@ -6336,14 +6576,14 @@
       </p:sp>
       <p:sp>
         <p:nvSpPr>
-          <p:cNvPr id="7" name="TextBox 6"/>
+          <p:cNvPr id="6" name="TextBox 5"/>
           <p:cNvSpPr txBox="1"/>
           <p:nvPr/>
         </p:nvSpPr>
         <p:spPr>
           <a:xfrm>
             <a:off x="914400" y="1828800"/>
-            <a:ext cx="2926080" cy="4023360"/>
+            <a:ext cx="4754880" cy="4389120"/>
           </a:xfrm>
           <a:prstGeom prst="rect">
             <a:avLst/>
@@ -6357,84 +6597,81 @@
           <a:lstStyle/>
           <a:p>
             <a:pPr>
+              <a:defRPr sz="1600" b="1">
+                <a:solidFill>
+                  <a:srgbClr val="38BDF8"/>
+                </a:solidFill>
+              </a:defRPr>
+            </a:pPr>
+            <a:r>
+              <a:t>🌐 High-Availability VPC Architecture</a:t>
+            </a:r>
+          </a:p>
+          <a:p>
+            <a:pPr>
               <a:spcAft>
-                <a:spcPts val="1200"/>
-              </a:spcAft>
-              <a:defRPr sz="1600" b="1">
-                <a:solidFill>
-                  <a:srgbClr val="38BDF8"/>
-                </a:solidFill>
-              </a:defRPr>
-            </a:pPr>
-            <a:r>
-              <a:t>💡 What Worked Well</a:t>
-            </a:r>
-          </a:p>
-          <a:p>
-            <a:pPr>
-              <a:spcAft>
-                <a:spcPts val="1000"/>
+                <a:spcPts val="800"/>
               </a:spcAft>
               <a:defRPr sz="1200">
                 <a:solidFill>
-                  <a:srgbClr val="F8FAFC"/>
-                </a:solidFill>
-              </a:defRPr>
-            </a:pPr>
-            <a:r>
-              <a:t>•  Multi-stage Docker builds reduced image sizes by over 60%.</a:t>
+                  <a:srgbClr val="CBD5E1"/>
+                </a:solidFill>
+              </a:defRPr>
+            </a:pPr>
+            <a:r>
+              <a:t>▸  Multi-AZ Topology: Dual Availability Zone architecture provisioned across ap-south-1a and ap-south-1b.</a:t>
             </a:r>
           </a:p>
           <a:p>
             <a:pPr>
               <a:spcAft>
-                <a:spcPts val="1000"/>
+                <a:spcPts val="800"/>
               </a:spcAft>
               <a:defRPr sz="1200">
                 <a:solidFill>
-                  <a:srgbClr val="F8FAFC"/>
-                </a:solidFill>
-              </a:defRPr>
-            </a:pPr>
-            <a:r>
-              <a:t>•  Pytest suite caught regression issues before containerization.</a:t>
+                  <a:srgbClr val="CBD5E1"/>
+                </a:solidFill>
+              </a:defRPr>
+            </a:pPr>
+            <a:r>
+              <a:t>▸  Public Subnets: 10.20.101.0/24 &amp; 10.20.102.0/24 with Internet Gateway and ELB discovery tags (kubernetes.io/role/elb = 1).</a:t>
             </a:r>
           </a:p>
           <a:p>
             <a:pPr>
               <a:spcAft>
-                <a:spcPts val="1000"/>
+                <a:spcPts val="800"/>
               </a:spcAft>
               <a:defRPr sz="1200">
                 <a:solidFill>
-                  <a:srgbClr val="F8FAFC"/>
-                </a:solidFill>
-              </a:defRPr>
-            </a:pPr>
-            <a:r>
-              <a:t>•  Automated Kind deployment verified manifests on every push.</a:t>
-            </a:r>
-          </a:p>
-        </p:txBody>
-      </p:sp>
-      <p:sp>
-        <p:nvSpPr>
-          <p:cNvPr id="8" name="Rounded Rectangle 7"/>
+                  <a:srgbClr val="CBD5E1"/>
+                </a:solidFill>
+              </a:defRPr>
+            </a:pPr>
+            <a:r>
+              <a:t>▸  Private Subnets: 10.20.1.0/24 &amp; 10.20.2.0/24 with NAT Gateway for secure worker node outbound egress.</a:t>
+            </a:r>
+          </a:p>
+        </p:txBody>
+      </p:sp>
+      <p:sp>
+        <p:nvSpPr>
+          <p:cNvPr id="7" name="Rounded Rectangle 6"/>
           <p:cNvSpPr/>
           <p:nvPr/>
         </p:nvSpPr>
         <p:spPr>
           <a:xfrm>
-            <a:off x="4480560" y="1645920"/>
-            <a:ext cx="3291840" cy="4389120"/>
+            <a:off x="6217920" y="1645920"/>
+            <a:ext cx="5120640" cy="4754880"/>
           </a:xfrm>
           <a:prstGeom prst="roundRect">
             <a:avLst/>
           </a:prstGeom>
           <a:solidFill>
-            <a:srgbClr val="161B22"/>
+            <a:srgbClr val="1E293B"/>
           </a:solidFill>
-          <a:ln w="12700">
+          <a:ln>
             <a:solidFill>
               <a:srgbClr val="334155"/>
             </a:solidFill>
@@ -6464,14 +6701,14 @@
       </p:sp>
       <p:sp>
         <p:nvSpPr>
-          <p:cNvPr id="9" name="TextBox 8"/>
+          <p:cNvPr id="8" name="TextBox 7"/>
           <p:cNvSpPr txBox="1"/>
           <p:nvPr/>
         </p:nvSpPr>
         <p:spPr>
           <a:xfrm>
-            <a:off x="4663440" y="1828800"/>
-            <a:ext cx="2926080" cy="4023360"/>
+            <a:off x="6400800" y="1828800"/>
+            <a:ext cx="4754880" cy="4389120"/>
           </a:xfrm>
           <a:prstGeom prst="rect">
             <a:avLst/>
@@ -6485,86 +6722,116 @@
           <a:lstStyle/>
           <a:p>
             <a:pPr>
+              <a:defRPr sz="1600" b="1">
+                <a:solidFill>
+                  <a:srgbClr val="38BDF8"/>
+                </a:solidFill>
+              </a:defRPr>
+            </a:pPr>
+            <a:r>
+              <a:t>☸️ Production EKS Cluster Design</a:t>
+            </a:r>
+          </a:p>
+          <a:p>
+            <a:pPr>
               <a:spcAft>
-                <a:spcPts val="1200"/>
-              </a:spcAft>
-              <a:defRPr sz="1600" b="1">
-                <a:solidFill>
-                  <a:srgbClr val="4ADE80"/>
-                </a:solidFill>
-              </a:defRPr>
-            </a:pPr>
-            <a:r>
-              <a:t>🔧 Challenges Overcome</a:t>
-            </a:r>
-          </a:p>
-          <a:p>
-            <a:pPr>
-              <a:spcAft>
-                <a:spcPts val="1000"/>
+                <a:spcPts val="800"/>
               </a:spcAft>
               <a:defRPr sz="1200">
                 <a:solidFill>
-                  <a:srgbClr val="F8FAFC"/>
-                </a:solidFill>
-              </a:defRPr>
-            </a:pPr>
-            <a:r>
-              <a:t>•  Fixed non-root Nginx port binding from port 80 to unprivileged 8080.</a:t>
+                  <a:srgbClr val="CBD5E1"/>
+                </a:solidFill>
+              </a:defRPr>
+            </a:pPr>
+            <a:r>
+              <a:t>▸  Control Plane: AWS EKS running Kubernetes 1.31 with managed IAM OIDC provider.</a:t>
             </a:r>
           </a:p>
           <a:p>
             <a:pPr>
               <a:spcAft>
-                <a:spcPts val="1000"/>
+                <a:spcPts val="800"/>
               </a:spcAft>
               <a:defRPr sz="1200">
                 <a:solidFill>
-                  <a:srgbClr val="F8FAFC"/>
-                </a:solidFill>
-              </a:defRPr>
-            </a:pPr>
-            <a:r>
-              <a:t>•  Resolved Docker repository casing restrictions (normalized to lowercase).</a:t>
+                  <a:srgbClr val="CBD5E1"/>
+                </a:solidFill>
+              </a:defRPr>
+            </a:pPr>
+            <a:r>
+              <a:t>▸  Managed Node Group: t3.medium EC2 instances (Min: 2, Max: 4, Desired: 2) across private subnets.</a:t>
             </a:r>
           </a:p>
           <a:p>
             <a:pPr>
               <a:spcAft>
-                <a:spcPts val="1000"/>
+                <a:spcPts val="800"/>
               </a:spcAft>
               <a:defRPr sz="1200">
                 <a:solidFill>
-                  <a:srgbClr val="F8FAFC"/>
-                </a:solidFill>
-              </a:defRPr>
-            </a:pPr>
-            <a:r>
-              <a:t>•  Audited and mitigated CVEs detected by Trivy scanner.</a:t>
-            </a:r>
-          </a:p>
-        </p:txBody>
-      </p:sp>
-      <p:sp>
-        <p:nvSpPr>
-          <p:cNvPr id="10" name="Rounded Rectangle 9"/>
+                  <a:srgbClr val="CBD5E1"/>
+                </a:solidFill>
+              </a:defRPr>
+            </a:pPr>
+            <a:r>
+              <a:t>▸  Code Hygiene &amp; Validation: 100% compliant with terraform fmt -check and terraform validate.</a:t>
+            </a:r>
+          </a:p>
+          <a:p>
+            <a:pPr>
+              <a:spcAft>
+                <a:spcPts val="800"/>
+              </a:spcAft>
+              <a:defRPr sz="1200">
+                <a:solidFill>
+                  <a:srgbClr val="CBD5E1"/>
+                </a:solidFill>
+              </a:defRPr>
+            </a:pPr>
+            <a:r>
+              <a:t>▸  Zero hardcoded secrets using parameterized variables via terraform.tfvars.example.</a:t>
+            </a:r>
+          </a:p>
+        </p:txBody>
+      </p:sp>
+    </p:spTree>
+  </p:cSld>
+  <p:clrMapOvr>
+    <a:masterClrMapping/>
+  </p:clrMapOvr>
+</p:sld>
+</file>
+
+<file path=ppt/slides/slide9.xml><?xml version="1.0" encoding="utf-8"?>
+<p:sld xmlns:a="http://schemas.openxmlformats.org/drawingml/2006/main" xmlns:p="http://schemas.openxmlformats.org/presentationml/2006/main" xmlns:r="http://schemas.openxmlformats.org/officeDocument/2006/relationships">
+  <p:cSld>
+    <p:spTree>
+      <p:nvGrpSpPr>
+        <p:cNvPr id="1" name=""/>
+        <p:cNvGrpSpPr/>
+        <p:nvPr/>
+      </p:nvGrpSpPr>
+      <p:grpSpPr/>
+      <p:sp>
+        <p:nvSpPr>
+          <p:cNvPr id="2" name="Rectangle 1"/>
           <p:cNvSpPr/>
           <p:nvPr/>
         </p:nvSpPr>
         <p:spPr>
           <a:xfrm>
-            <a:off x="8229600" y="1645920"/>
-            <a:ext cx="3291840" cy="4389120"/>
-          </a:xfrm>
-          <a:prstGeom prst="roundRect">
+            <a:off x="0" y="0"/>
+            <a:ext cx="12191695" cy="6858000"/>
+          </a:xfrm>
+          <a:prstGeom prst="rect">
             <a:avLst/>
           </a:prstGeom>
           <a:solidFill>
-            <a:srgbClr val="161B22"/>
+            <a:srgbClr val="0B0F19"/>
           </a:solidFill>
-          <a:ln w="12700">
+          <a:ln>
             <a:solidFill>
-              <a:srgbClr val="334155"/>
+              <a:srgbClr val="0B0F19"/>
             </a:solidFill>
           </a:ln>
         </p:spPr>
@@ -6592,14 +6859,14 @@
       </p:sp>
       <p:sp>
         <p:nvSpPr>
-          <p:cNvPr id="11" name="TextBox 10"/>
+          <p:cNvPr id="3" name="TextBox 2"/>
           <p:cNvSpPr txBox="1"/>
           <p:nvPr/>
         </p:nvSpPr>
         <p:spPr>
           <a:xfrm>
-            <a:off x="8412480" y="1828800"/>
-            <a:ext cx="2926080" cy="4023360"/>
+            <a:off x="731520" y="365760"/>
+            <a:ext cx="10698480" cy="457200"/>
           </a:xfrm>
           <a:prstGeom prst="rect">
             <a:avLst/>
@@ -6613,62 +6880,329 @@
           <a:lstStyle/>
           <a:p>
             <a:pPr>
+              <a:defRPr sz="1100" b="1">
+                <a:solidFill>
+                  <a:srgbClr val="38BDF8"/>
+                </a:solidFill>
+              </a:defRPr>
+            </a:pPr>
+            <a:r>
+              <a:t>Slide 09 / 10    |    Aadish Sharma — OpsDesk Capstone</a:t>
+            </a:r>
+          </a:p>
+        </p:txBody>
+      </p:sp>
+      <p:sp>
+        <p:nvSpPr>
+          <p:cNvPr id="4" name="TextBox 3"/>
+          <p:cNvSpPr txBox="1"/>
+          <p:nvPr/>
+        </p:nvSpPr>
+        <p:spPr>
+          <a:xfrm>
+            <a:off x="731520" y="822960"/>
+            <a:ext cx="10698480" cy="731520"/>
+          </a:xfrm>
+          <a:prstGeom prst="rect">
+            <a:avLst/>
+          </a:prstGeom>
+          <a:noFill/>
+        </p:spPr>
+        <p:txBody>
+          <a:bodyPr wrap="square">
+            <a:spAutoFit/>
+          </a:bodyPr>
+          <a:lstStyle/>
+          <a:p>
+            <a:pPr>
+              <a:defRPr sz="2800" b="1">
+                <a:solidFill>
+                  <a:srgbClr val="F8FAFC"/>
+                </a:solidFill>
+              </a:defRPr>
+            </a:pPr>
+            <a:r>
+              <a:t>Kubernetes (Helm) &amp; Observability</a:t>
+            </a:r>
+          </a:p>
+        </p:txBody>
+      </p:sp>
+      <p:sp>
+        <p:nvSpPr>
+          <p:cNvPr id="5" name="Rounded Rectangle 4"/>
+          <p:cNvSpPr/>
+          <p:nvPr/>
+        </p:nvSpPr>
+        <p:spPr>
+          <a:xfrm>
+            <a:off x="731520" y="1645920"/>
+            <a:ext cx="5120640" cy="4754880"/>
+          </a:xfrm>
+          <a:prstGeom prst="roundRect">
+            <a:avLst/>
+          </a:prstGeom>
+          <a:solidFill>
+            <a:srgbClr val="1E293B"/>
+          </a:solidFill>
+          <a:ln>
+            <a:solidFill>
+              <a:srgbClr val="334155"/>
+            </a:solidFill>
+          </a:ln>
+        </p:spPr>
+        <p:style>
+          <a:lnRef idx="1">
+            <a:schemeClr val="accent1"/>
+          </a:lnRef>
+          <a:fillRef idx="3">
+            <a:schemeClr val="accent1"/>
+          </a:fillRef>
+          <a:effectRef idx="2">
+            <a:schemeClr val="accent1"/>
+          </a:effectRef>
+          <a:fontRef idx="minor">
+            <a:schemeClr val="lt1"/>
+          </a:fontRef>
+        </p:style>
+        <p:txBody>
+          <a:bodyPr rtlCol="0" anchor="ctr"/>
+          <a:lstStyle/>
+          <a:p>
+            <a:pPr algn="ctr"/>
+          </a:p>
+        </p:txBody>
+      </p:sp>
+      <p:sp>
+        <p:nvSpPr>
+          <p:cNvPr id="6" name="TextBox 5"/>
+          <p:cNvSpPr txBox="1"/>
+          <p:nvPr/>
+        </p:nvSpPr>
+        <p:spPr>
+          <a:xfrm>
+            <a:off x="914400" y="1828800"/>
+            <a:ext cx="4754880" cy="4389120"/>
+          </a:xfrm>
+          <a:prstGeom prst="rect">
+            <a:avLst/>
+          </a:prstGeom>
+          <a:noFill/>
+        </p:spPr>
+        <p:txBody>
+          <a:bodyPr wrap="square">
+            <a:spAutoFit/>
+          </a:bodyPr>
+          <a:lstStyle/>
+          <a:p>
+            <a:pPr>
+              <a:defRPr sz="1600" b="1">
+                <a:solidFill>
+                  <a:srgbClr val="38BDF8"/>
+                </a:solidFill>
+              </a:defRPr>
+            </a:pPr>
+            <a:r>
+              <a:t>📦 Production Helm Packaging</a:t>
+            </a:r>
+          </a:p>
+          <a:p>
+            <a:pPr>
               <a:spcAft>
-                <a:spcPts val="1200"/>
-              </a:spcAft>
-              <a:defRPr sz="1600" b="1">
-                <a:solidFill>
-                  <a:srgbClr val="94A3B8"/>
-                </a:solidFill>
-              </a:defRPr>
-            </a:pPr>
-            <a:r>
-              <a:t>🏆 Final Outcome</a:t>
-            </a:r>
-          </a:p>
-          <a:p>
-            <a:pPr>
-              <a:spcAft>
-                <a:spcPts val="1000"/>
+                <a:spcPts val="800"/>
               </a:spcAft>
               <a:defRPr sz="1200">
                 <a:solidFill>
-                  <a:srgbClr val="F8FAFC"/>
-                </a:solidFill>
-              </a:defRPr>
-            </a:pPr>
-            <a:r>
-              <a:t>•  100% compliant with all 10 Capstone grading rubric modules.</a:t>
+                  <a:srgbClr val="CBD5E1"/>
+                </a:solidFill>
+              </a:defRPr>
+            </a:pPr>
+            <a:r>
+              <a:t>▸  Modular Chart: Helm package (helm/taskboard) with environment values overlays (values.yaml and values-prod.yaml).</a:t>
             </a:r>
           </a:p>
           <a:p>
             <a:pPr>
               <a:spcAft>
-                <a:spcPts val="1000"/>
+                <a:spcPts val="800"/>
               </a:spcAft>
               <a:defRPr sz="1200">
                 <a:solidFill>
-                  <a:srgbClr val="F8FAFC"/>
-                </a:solidFill>
-              </a:defRPr>
-            </a:pPr>
-            <a:r>
-              <a:t>•  Production-ready code, tests, CI/CD, IaC, and monitoring stack.</a:t>
+                  <a:srgbClr val="CBD5E1"/>
+                </a:solidFill>
+              </a:defRPr>
+            </a:pPr>
+            <a:r>
+              <a:t>▸  Resilient Deployments: ClusterIP services for backend (port 8000) and frontend (port 8080) with Ingress gateway routing.</a:t>
             </a:r>
           </a:p>
           <a:p>
             <a:pPr>
               <a:spcAft>
-                <a:spcPts val="1000"/>
+                <a:spcPts val="800"/>
               </a:spcAft>
               <a:defRPr sz="1200">
                 <a:solidFill>
-                  <a:srgbClr val="F8FAFC"/>
-                </a:solidFill>
-              </a:defRPr>
-            </a:pPr>
-            <a:r>
-              <a:t>•  Complete visual evidence documentation in screenshots/ directory.</a:t>
+                  <a:srgbClr val="CBD5E1"/>
+                </a:solidFill>
+              </a:defRPr>
+            </a:pPr>
+            <a:r>
+              <a:t>▸  Dynamic Autoscaling: Horizontal Pod Autoscaler (HPA) configured for CPU-based pod scaling.</a:t>
+            </a:r>
+          </a:p>
+          <a:p>
+            <a:pPr>
+              <a:spcAft>
+                <a:spcPts val="800"/>
+              </a:spcAft>
+              <a:defRPr sz="1200">
+                <a:solidFill>
+                  <a:srgbClr val="CBD5E1"/>
+                </a:solidFill>
+              </a:defRPr>
+            </a:pPr>
+            <a:r>
+              <a:t>▸  Health Probes: Liveness and readiness probes active on /health and /ready endpoints.</a:t>
+            </a:r>
+          </a:p>
+        </p:txBody>
+      </p:sp>
+      <p:sp>
+        <p:nvSpPr>
+          <p:cNvPr id="7" name="Rounded Rectangle 6"/>
+          <p:cNvSpPr/>
+          <p:nvPr/>
+        </p:nvSpPr>
+        <p:spPr>
+          <a:xfrm>
+            <a:off x="6217920" y="1645920"/>
+            <a:ext cx="5120640" cy="4754880"/>
+          </a:xfrm>
+          <a:prstGeom prst="roundRect">
+            <a:avLst/>
+          </a:prstGeom>
+          <a:solidFill>
+            <a:srgbClr val="1E293B"/>
+          </a:solidFill>
+          <a:ln>
+            <a:solidFill>
+              <a:srgbClr val="334155"/>
+            </a:solidFill>
+          </a:ln>
+        </p:spPr>
+        <p:style>
+          <a:lnRef idx="1">
+            <a:schemeClr val="accent1"/>
+          </a:lnRef>
+          <a:fillRef idx="3">
+            <a:schemeClr val="accent1"/>
+          </a:fillRef>
+          <a:effectRef idx="2">
+            <a:schemeClr val="accent1"/>
+          </a:effectRef>
+          <a:fontRef idx="minor">
+            <a:schemeClr val="lt1"/>
+          </a:fontRef>
+        </p:style>
+        <p:txBody>
+          <a:bodyPr rtlCol="0" anchor="ctr"/>
+          <a:lstStyle/>
+          <a:p>
+            <a:pPr algn="ctr"/>
+          </a:p>
+        </p:txBody>
+      </p:sp>
+      <p:sp>
+        <p:nvSpPr>
+          <p:cNvPr id="8" name="TextBox 7"/>
+          <p:cNvSpPr txBox="1"/>
+          <p:nvPr/>
+        </p:nvSpPr>
+        <p:spPr>
+          <a:xfrm>
+            <a:off x="6400800" y="1828800"/>
+            <a:ext cx="4754880" cy="4389120"/>
+          </a:xfrm>
+          <a:prstGeom prst="rect">
+            <a:avLst/>
+          </a:prstGeom>
+          <a:noFill/>
+        </p:spPr>
+        <p:txBody>
+          <a:bodyPr wrap="square">
+            <a:spAutoFit/>
+          </a:bodyPr>
+          <a:lstStyle/>
+          <a:p>
+            <a:pPr>
+              <a:defRPr sz="1600" b="1">
+                <a:solidFill>
+                  <a:srgbClr val="38BDF8"/>
+                </a:solidFill>
+              </a:defRPr>
+            </a:pPr>
+            <a:r>
+              <a:t>📊 Prometheus &amp; Grafana Telemetry</a:t>
+            </a:r>
+          </a:p>
+          <a:p>
+            <a:pPr>
+              <a:spcAft>
+                <a:spcPts val="800"/>
+              </a:spcAft>
+              <a:defRPr sz="1200">
+                <a:solidFill>
+                  <a:srgbClr val="CBD5E1"/>
+                </a:solidFill>
+              </a:defRPr>
+            </a:pPr>
+            <a:r>
+              <a:t>▸  Application Instrumentation: FastAPI backend instrumented with prometheus-fastapi-instrumentator.</a:t>
+            </a:r>
+          </a:p>
+          <a:p>
+            <a:pPr>
+              <a:spcAft>
+                <a:spcPts val="800"/>
+              </a:spcAft>
+              <a:defRPr sz="1200">
+                <a:solidFill>
+                  <a:srgbClr val="CBD5E1"/>
+                </a:solidFill>
+              </a:defRPr>
+            </a:pPr>
+            <a:r>
+              <a:t>▸  Metrics Endpoint: Exposes live request counters, HTTP latency histograms, and memory gauges on /metrics.</a:t>
+            </a:r>
+          </a:p>
+          <a:p>
+            <a:pPr>
+              <a:spcAft>
+                <a:spcPts val="800"/>
+              </a:spcAft>
+              <a:defRPr sz="1200">
+                <a:solidFill>
+                  <a:srgbClr val="CBD5E1"/>
+                </a:solidFill>
+              </a:defRPr>
+            </a:pPr>
+            <a:r>
+              <a:t>▸  Prometheus Scraper: Pulls telemetry every 15s interval via Kubernetes ServiceMonitor.</a:t>
+            </a:r>
+          </a:p>
+          <a:p>
+            <a:pPr>
+              <a:spcAft>
+                <a:spcPts val="800"/>
+              </a:spcAft>
+              <a:defRPr sz="1200">
+                <a:solidFill>
+                  <a:srgbClr val="CBD5E1"/>
+                </a:solidFill>
+              </a:defRPr>
+            </a:pPr>
+            <a:r>
+              <a:t>▸  Grafana Dashboards: Pre-configured visual analytics for request throughput, error rates, and cluster health.</a:t>
             </a:r>
           </a:p>
         </p:txBody>

</xml_diff>